<commit_message>
Module 3 rebuild + 2026 currency revision (78-slide draft)
Final 78-slide Module 3_NEW_draft.pptx built via direct zip+lxml
surgery on Module 3.pptx (python-pptx round-trip strips NULL image
rels and corrupts this deck; see Session-Notes for the gotcha).

- 10 redundant slides cut, 5 new template-styled slides inserted
- Tesla → Rivian on 9 long-run / cost-function slides
- 3 AI examples: AI researcher poaching, ChatGPT subscription tiers,
  AI training scale (with NVIDIA H100 imagery)
- iPhone 11 → iPhone 17, Airbus A380/A318 → Alphabet
- Meta Reality Labs added as modern sunk-cost parallel to Waterworld
- All 78 slides have MBA-friendly speaker notes
- Real photographs sourced from Wikimedia (CC BY-SA / PD)

Co-Authored-By: Claude Opus 4.7 (1M context) <noreply@anthropic.com>
</commit_message>
<xml_diff>
--- a/405 Slide Revisions 2026/Module 3/405 Slides Template.pptx
+++ b/405 Slide Revisions 2026/Module 3/405 Slides Template.pptx
@@ -6,6 +6,11 @@
   </p:sldMasterIdLst>
   <p:sldIdLst>
     <p:sldId id="256" r:id="rId7"/>
+    <p:sldId id="257" r:id="rId8"/>
+    <p:sldId id="258" r:id="rId9"/>
+    <p:sldId id="259" r:id="rId10"/>
+    <p:sldId id="260" r:id="rId11"/>
+    <p:sldId id="261" r:id="rId12"/>
   </p:sldIdLst>
   <p:sldSz cx="12191695" cy="6858000" type="screen4x3"/>
   <p:notesSz cx="6858000" cy="9144000"/>
@@ -3090,6 +3095,296 @@
       <p:grpSpPr/>
       <p:sp>
         <p:nvSpPr>
+          <p:cNvPr id="2" name="TextBox 1"/>
+          <p:cNvSpPr txBox="1"/>
+          <p:nvPr/>
+        </p:nvSpPr>
+        <p:spPr>
+          <a:xfrm>
+            <a:off x="251999" y="1828800"/>
+            <a:ext cx="11687697" cy="1188720"/>
+          </a:xfrm>
+          <a:prstGeom prst="rect">
+            <a:avLst/>
+          </a:prstGeom>
+          <a:noFill/>
+        </p:spPr>
+        <p:txBody>
+          <a:bodyPr wrap="square" lIns="0" rIns="0" tIns="0" bIns="0">
+            <a:spAutoFit/>
+          </a:bodyPr>
+          <a:lstStyle/>
+          <a:p>
+            <a:pPr algn="ctr"/>
+            <a:r>
+              <a:rPr sz="6000" b="1" i="0">
+                <a:solidFill>
+                  <a:srgbClr val="0B2B4E"/>
+                </a:solidFill>
+                <a:latin typeface="Calibri"/>
+              </a:rPr>
+              <a:t>Production and Costs</a:t>
+            </a:r>
+          </a:p>
+        </p:txBody>
+      </p:sp>
+      <p:sp>
+        <p:nvSpPr>
+          <p:cNvPr id="3" name="TextBox 2"/>
+          <p:cNvSpPr txBox="1"/>
+          <p:nvPr/>
+        </p:nvSpPr>
+        <p:spPr>
+          <a:xfrm>
+            <a:off x="251999" y="3063240"/>
+            <a:ext cx="11687697" cy="685800"/>
+          </a:xfrm>
+          <a:prstGeom prst="rect">
+            <a:avLst/>
+          </a:prstGeom>
+          <a:noFill/>
+        </p:spPr>
+        <p:txBody>
+          <a:bodyPr wrap="square" lIns="0" rIns="0" tIns="0" bIns="0">
+            <a:spAutoFit/>
+          </a:bodyPr>
+          <a:lstStyle/>
+          <a:p>
+            <a:pPr algn="ctr"/>
+            <a:r>
+              <a:rPr sz="4000" b="1" i="0">
+                <a:solidFill>
+                  <a:srgbClr val="E09F3E"/>
+                </a:solidFill>
+                <a:latin typeface="Calibri"/>
+              </a:rPr>
+              <a:t>Module 3</a:t>
+            </a:r>
+          </a:p>
+        </p:txBody>
+      </p:sp>
+      <p:sp>
+        <p:nvSpPr>
+          <p:cNvPr id="4" name="Rectangle 3"/>
+          <p:cNvSpPr/>
+          <p:nvPr/>
+        </p:nvSpPr>
+        <p:spPr>
+          <a:xfrm>
+            <a:off x="4267047" y="4023360"/>
+            <a:ext cx="3657600" cy="54864"/>
+          </a:xfrm>
+          <a:prstGeom prst="rect">
+            <a:avLst/>
+          </a:prstGeom>
+          <a:solidFill>
+            <a:srgbClr val="E09F3E"/>
+          </a:solidFill>
+          <a:ln>
+            <a:noFill/>
+          </a:ln>
+          <a:effectLst/>
+        </p:spPr>
+        <p:style>
+          <a:lnRef idx="1">
+            <a:schemeClr val="accent1"/>
+          </a:lnRef>
+          <a:fillRef idx="3">
+            <a:schemeClr val="accent1"/>
+          </a:fillRef>
+          <a:effectRef idx="2">
+            <a:schemeClr val="accent1"/>
+          </a:effectRef>
+          <a:fontRef idx="minor">
+            <a:schemeClr val="lt1"/>
+          </a:fontRef>
+        </p:style>
+        <p:txBody>
+          <a:bodyPr rtlCol="0" anchor="ctr"/>
+          <a:lstStyle/>
+          <a:p>
+            <a:pPr algn="ctr"/>
+          </a:p>
+        </p:txBody>
+      </p:sp>
+      <p:sp>
+        <p:nvSpPr>
+          <p:cNvPr id="5" name="TextBox 4"/>
+          <p:cNvSpPr txBox="1"/>
+          <p:nvPr/>
+        </p:nvSpPr>
+        <p:spPr>
+          <a:xfrm>
+            <a:off x="251999" y="4389120"/>
+            <a:ext cx="11687697" cy="502920"/>
+          </a:xfrm>
+          <a:prstGeom prst="rect">
+            <a:avLst/>
+          </a:prstGeom>
+          <a:noFill/>
+        </p:spPr>
+        <p:txBody>
+          <a:bodyPr wrap="square" lIns="0" rIns="0" tIns="0" bIns="0">
+            <a:spAutoFit/>
+          </a:bodyPr>
+          <a:lstStyle/>
+          <a:p>
+            <a:pPr algn="ctr"/>
+            <a:r>
+              <a:rPr sz="2600" b="1" i="0">
+                <a:solidFill>
+                  <a:srgbClr val="555B66"/>
+                </a:solidFill>
+                <a:latin typeface="Calibri"/>
+              </a:rPr>
+              <a:t>Management 405  ·  EMBA</a:t>
+            </a:r>
+          </a:p>
+        </p:txBody>
+      </p:sp>
+      <p:sp>
+        <p:nvSpPr>
+          <p:cNvPr id="6" name="TextBox 5"/>
+          <p:cNvSpPr txBox="1"/>
+          <p:nvPr/>
+        </p:nvSpPr>
+        <p:spPr>
+          <a:xfrm>
+            <a:off x="251999" y="5029200"/>
+            <a:ext cx="11687697" cy="457200"/>
+          </a:xfrm>
+          <a:prstGeom prst="rect">
+            <a:avLst/>
+          </a:prstGeom>
+          <a:noFill/>
+        </p:spPr>
+        <p:txBody>
+          <a:bodyPr wrap="square" lIns="0" rIns="0" tIns="0" bIns="0">
+            <a:spAutoFit/>
+          </a:bodyPr>
+          <a:lstStyle/>
+          <a:p>
+            <a:pPr algn="ctr"/>
+            <a:r>
+              <a:rPr sz="2200" b="0" i="0">
+                <a:solidFill>
+                  <a:srgbClr val="555B66"/>
+                </a:solidFill>
+                <a:latin typeface="Calibri"/>
+              </a:rPr>
+              <a:t>Prof. Nico Voigtlaender  ·  UCLA Anderson</a:t>
+            </a:r>
+          </a:p>
+        </p:txBody>
+      </p:sp>
+      <p:sp>
+        <p:nvSpPr>
+          <p:cNvPr id="7" name="Rectangle 6"/>
+          <p:cNvSpPr/>
+          <p:nvPr/>
+        </p:nvSpPr>
+        <p:spPr>
+          <a:xfrm>
+            <a:off x="0" y="6537960"/>
+            <a:ext cx="12191695" cy="18288"/>
+          </a:xfrm>
+          <a:prstGeom prst="rect">
+            <a:avLst/>
+          </a:prstGeom>
+          <a:solidFill>
+            <a:srgbClr val="C8CDD3"/>
+          </a:solidFill>
+          <a:ln>
+            <a:noFill/>
+          </a:ln>
+          <a:effectLst/>
+        </p:spPr>
+        <p:style>
+          <a:lnRef idx="1">
+            <a:schemeClr val="accent1"/>
+          </a:lnRef>
+          <a:fillRef idx="3">
+            <a:schemeClr val="accent1"/>
+          </a:fillRef>
+          <a:effectRef idx="2">
+            <a:schemeClr val="accent1"/>
+          </a:effectRef>
+          <a:fontRef idx="minor">
+            <a:schemeClr val="lt1"/>
+          </a:fontRef>
+        </p:style>
+        <p:txBody>
+          <a:bodyPr rtlCol="0" anchor="ctr"/>
+          <a:lstStyle/>
+          <a:p>
+            <a:pPr algn="ctr"/>
+          </a:p>
+        </p:txBody>
+      </p:sp>
+      <p:sp>
+        <p:nvSpPr>
+          <p:cNvPr id="8" name="Rectangle 7"/>
+          <p:cNvSpPr/>
+          <p:nvPr/>
+        </p:nvSpPr>
+        <p:spPr>
+          <a:xfrm>
+            <a:off x="251999" y="6524244"/>
+            <a:ext cx="2011680" cy="45720"/>
+          </a:xfrm>
+          <a:prstGeom prst="rect">
+            <a:avLst/>
+          </a:prstGeom>
+          <a:solidFill>
+            <a:srgbClr val="E09F3E"/>
+          </a:solidFill>
+          <a:ln>
+            <a:noFill/>
+          </a:ln>
+          <a:effectLst/>
+        </p:spPr>
+        <p:style>
+          <a:lnRef idx="1">
+            <a:schemeClr val="accent1"/>
+          </a:lnRef>
+          <a:fillRef idx="3">
+            <a:schemeClr val="accent1"/>
+          </a:fillRef>
+          <a:effectRef idx="2">
+            <a:schemeClr val="accent1"/>
+          </a:effectRef>
+          <a:fontRef idx="minor">
+            <a:schemeClr val="lt1"/>
+          </a:fontRef>
+        </p:style>
+        <p:txBody>
+          <a:bodyPr rtlCol="0" anchor="ctr"/>
+          <a:lstStyle/>
+          <a:p>
+            <a:pPr algn="ctr"/>
+          </a:p>
+        </p:txBody>
+      </p:sp>
+    </p:spTree>
+  </p:cSld>
+  <p:clrMapOvr>
+    <a:masterClrMapping/>
+  </p:clrMapOvr>
+</p:sld>
+</file>
+
+<file path=ppt/slides/slide2.xml><?xml version="1.0" encoding="utf-8"?>
+<p:sld xmlns:a="http://schemas.openxmlformats.org/drawingml/2006/main" xmlns:p="http://schemas.openxmlformats.org/presentationml/2006/main" xmlns:r="http://schemas.openxmlformats.org/officeDocument/2006/relationships">
+  <p:cSld>
+    <p:spTree>
+      <p:nvGrpSpPr>
+        <p:cNvPr id="1" name=""/>
+        <p:cNvGrpSpPr/>
+        <p:nvPr/>
+      </p:nvGrpSpPr>
+      <p:grpSpPr/>
+      <p:sp>
+        <p:nvSpPr>
           <p:cNvPr id="2" name="Rectangle 1"/>
           <p:cNvSpPr/>
           <p:nvPr/>
@@ -3149,7 +3444,7 @@
           <a:noFill/>
         </p:spPr>
         <p:txBody>
-          <a:bodyPr wrap="square" anchor="ctr">
+          <a:bodyPr wrap="square" lIns="0" rIns="0" tIns="0" bIns="0" anchor="ctr">
             <a:spAutoFit/>
           </a:bodyPr>
           <a:lstStyle/>
@@ -3162,7 +3457,7 @@
                 </a:solidFill>
                 <a:latin typeface="Calibri"/>
               </a:rPr>
-              <a:t>MODULE 3 · PART 2 · COSTS</a:t>
+              <a:t>MODULE 3 · SECTION DIVIDER</a:t>
             </a:r>
           </a:p>
         </p:txBody>
@@ -3184,7 +3479,7 @@
           <a:noFill/>
         </p:spPr>
         <p:txBody>
-          <a:bodyPr wrap="square">
+          <a:bodyPr wrap="square" lIns="0" rIns="0" tIns="0" bIns="0">
             <a:spAutoFit/>
           </a:bodyPr>
           <a:lstStyle/>
@@ -3197,7 +3492,7 @@
                 </a:solidFill>
                 <a:latin typeface="Calibri"/>
               </a:rPr>
-              <a:t>Sunk costs should never drive decisions</a:t>
+              <a:t>Agenda</a:t>
             </a:r>
           </a:p>
         </p:txBody>
@@ -3298,8 +3593,8 @@
         </p:nvSpPr>
         <p:spPr>
           <a:xfrm>
-            <a:off x="251999" y="1600200"/>
-            <a:ext cx="2926080" cy="868680"/>
+            <a:off x="251999" y="1691640"/>
+            <a:ext cx="11687697" cy="548640"/>
           </a:xfrm>
           <a:prstGeom prst="rect">
             <a:avLst/>
@@ -3307,20 +3602,20 @@
           <a:noFill/>
         </p:spPr>
         <p:txBody>
-          <a:bodyPr wrap="square">
+          <a:bodyPr wrap="square" lIns="0" rIns="0" tIns="0" bIns="0">
             <a:spAutoFit/>
           </a:bodyPr>
           <a:lstStyle/>
           <a:p>
             <a:pPr algn="l"/>
             <a:r>
-              <a:rPr sz="1800" b="1" i="0">
+              <a:rPr sz="3000" b="1" i="0">
                 <a:solidFill>
                   <a:srgbClr val="0B2B4E"/>
                 </a:solidFill>
                 <a:latin typeface="Calibri"/>
               </a:rPr>
-              <a:t>Fixed costs</a:t>
+              <a:t>Part 1: Production – Picking the Right Inputs</a:t>
             </a:r>
           </a:p>
         </p:txBody>
@@ -3333,8 +3628,8 @@
         </p:nvSpPr>
         <p:spPr>
           <a:xfrm>
-            <a:off x="3360959" y="1600200"/>
-            <a:ext cx="8578737" cy="868680"/>
+            <a:off x="617759" y="2240280"/>
+            <a:ext cx="11321937" cy="1234440"/>
           </a:xfrm>
           <a:prstGeom prst="rect">
             <a:avLst/>
@@ -3342,20 +3637,47 @@
           <a:noFill/>
         </p:spPr>
         <p:txBody>
-          <a:bodyPr wrap="square">
+          <a:bodyPr wrap="square" lIns="0" rIns="0" tIns="0" bIns="0">
             <a:spAutoFit/>
           </a:bodyPr>
           <a:lstStyle/>
           <a:p>
-            <a:pPr algn="l"/>
-            <a:r>
-              <a:rPr sz="1800" b="0" i="0">
-                <a:solidFill>
-                  <a:srgbClr val="555B66"/>
+            <a:pPr algn="l" marL="457200" indent="-457200">
+              <a:buClr>
+                <a:srgbClr val="0B2B4E"/>
+              </a:buClr>
+              <a:buFont typeface="Calibri"/>
+              <a:buAutoNum type="alphaLcPeriod"/>
+            </a:pPr>
+            <a:r>
+              <a:rPr sz="2400" b="0">
+                <a:solidFill>
+                  <a:srgbClr val="0B2B4E"/>
                 </a:solidFill>
                 <a:latin typeface="Calibri"/>
               </a:rPr>
-              <a:t>don't depend on quantity produced (Q)</a:t>
+              <a:t>Short Run – Hiring Decisions</a:t>
+            </a:r>
+          </a:p>
+          <a:p>
+            <a:pPr algn="l" marL="457200" indent="-457200">
+              <a:spcBef>
+                <a:spcPts val="1000"/>
+              </a:spcBef>
+              <a:buClr>
+                <a:srgbClr val="0B2B4E"/>
+              </a:buClr>
+              <a:buFont typeface="Calibri"/>
+              <a:buAutoNum type="alphaLcPeriod"/>
+            </a:pPr>
+            <a:r>
+              <a:rPr sz="2400" b="0">
+                <a:solidFill>
+                  <a:srgbClr val="0B2B4E"/>
+                </a:solidFill>
+                <a:latin typeface="Calibri"/>
+              </a:rPr>
+              <a:t>Long Run – Optimal Input Mix</a:t>
             </a:r>
           </a:p>
         </p:txBody>
@@ -3368,8 +3690,8 @@
         </p:nvSpPr>
         <p:spPr>
           <a:xfrm>
-            <a:off x="251999" y="2468880"/>
-            <a:ext cx="2926080" cy="868680"/>
+            <a:off x="251999" y="3611880"/>
+            <a:ext cx="11687697" cy="548640"/>
           </a:xfrm>
           <a:prstGeom prst="rect">
             <a:avLst/>
@@ -3377,20 +3699,20 @@
           <a:noFill/>
         </p:spPr>
         <p:txBody>
-          <a:bodyPr wrap="square">
+          <a:bodyPr wrap="square" lIns="0" rIns="0" tIns="0" bIns="0">
             <a:spAutoFit/>
           </a:bodyPr>
           <a:lstStyle/>
           <a:p>
             <a:pPr algn="l"/>
             <a:r>
-              <a:rPr sz="1800" b="1" i="0">
-                <a:solidFill>
-                  <a:srgbClr val="0B2B4E"/>
+              <a:rPr sz="3000" b="1" i="0">
+                <a:solidFill>
+                  <a:srgbClr val="B0B5BC"/>
                 </a:solidFill>
                 <a:latin typeface="Calibri"/>
               </a:rPr>
-              <a:t>Sunk costs</a:t>
+              <a:t>Part 2: Costs – Producing at the Lowest Price</a:t>
             </a:r>
           </a:p>
         </p:txBody>
@@ -3403,8 +3725,8 @@
         </p:nvSpPr>
         <p:spPr>
           <a:xfrm>
-            <a:off x="3360959" y="2468880"/>
-            <a:ext cx="8578737" cy="868680"/>
+            <a:off x="617759" y="4160520"/>
+            <a:ext cx="11321937" cy="1234440"/>
           </a:xfrm>
           <a:prstGeom prst="rect">
             <a:avLst/>
@@ -3412,167 +3734,54 @@
           <a:noFill/>
         </p:spPr>
         <p:txBody>
-          <a:bodyPr wrap="square">
+          <a:bodyPr wrap="square" lIns="0" rIns="0" tIns="0" bIns="0">
             <a:spAutoFit/>
           </a:bodyPr>
           <a:lstStyle/>
           <a:p>
-            <a:pPr algn="l"/>
-            <a:r>
-              <a:rPr sz="1800" b="0" i="0">
-                <a:solidFill>
-                  <a:srgbClr val="555B66"/>
+            <a:pPr algn="l" marL="457200" indent="-457200">
+              <a:buClr>
+                <a:srgbClr val="B0B5BC"/>
+              </a:buClr>
+              <a:buFont typeface="Calibri"/>
+              <a:buAutoNum type="alphaLcPeriod"/>
+            </a:pPr>
+            <a:r>
+              <a:rPr sz="2400" b="0">
+                <a:solidFill>
+                  <a:srgbClr val="B0B5BC"/>
                 </a:solidFill>
                 <a:latin typeface="Calibri"/>
               </a:rPr>
-              <a:t>a fixed cost that cannot be recovered</a:t>
-            </a:r>
-          </a:p>
-        </p:txBody>
-      </p:sp>
-      <p:sp>
-        <p:nvSpPr>
-          <p:cNvPr id="11" name="TextBox 10"/>
-          <p:cNvSpPr txBox="1"/>
-          <p:nvPr/>
-        </p:nvSpPr>
-        <p:spPr>
-          <a:xfrm>
-            <a:off x="251999" y="3337560"/>
-            <a:ext cx="2926080" cy="868680"/>
-          </a:xfrm>
-          <a:prstGeom prst="rect">
-            <a:avLst/>
-          </a:prstGeom>
-          <a:noFill/>
-        </p:spPr>
-        <p:txBody>
-          <a:bodyPr wrap="square">
-            <a:spAutoFit/>
-          </a:bodyPr>
-          <a:lstStyle/>
-          <a:p>
-            <a:pPr algn="l"/>
-            <a:r>
-              <a:rPr sz="1800" b="1" i="0">
-                <a:solidFill>
-                  <a:srgbClr val="0B2B4E"/>
+              <a:t>Cost Concepts</a:t>
+            </a:r>
+          </a:p>
+          <a:p>
+            <a:pPr algn="l" marL="457200" indent="-457200">
+              <a:spcBef>
+                <a:spcPts val="1000"/>
+              </a:spcBef>
+              <a:buClr>
+                <a:srgbClr val="B0B5BC"/>
+              </a:buClr>
+              <a:buFont typeface="Calibri"/>
+              <a:buAutoNum type="alphaLcPeriod"/>
+            </a:pPr>
+            <a:r>
+              <a:rPr sz="2400" b="0">
+                <a:solidFill>
+                  <a:srgbClr val="B0B5BC"/>
                 </a:solidFill>
                 <a:latin typeface="Calibri"/>
               </a:rPr>
-              <a:t>→ Decision rule</a:t>
-            </a:r>
-          </a:p>
-        </p:txBody>
-      </p:sp>
-      <p:sp>
-        <p:nvSpPr>
-          <p:cNvPr id="12" name="TextBox 11"/>
-          <p:cNvSpPr txBox="1"/>
-          <p:nvPr/>
-        </p:nvSpPr>
-        <p:spPr>
-          <a:xfrm>
-            <a:off x="3360959" y="3337560"/>
-            <a:ext cx="8578737" cy="868680"/>
-          </a:xfrm>
-          <a:prstGeom prst="rect">
-            <a:avLst/>
-          </a:prstGeom>
-          <a:noFill/>
-        </p:spPr>
-        <p:txBody>
-          <a:bodyPr wrap="square">
-            <a:spAutoFit/>
-          </a:bodyPr>
-          <a:lstStyle/>
-          <a:p>
-            <a:pPr algn="l"/>
-            <a:r>
-              <a:rPr sz="1800" b="0" i="0">
-                <a:solidFill>
-                  <a:srgbClr val="555B66"/>
-                </a:solidFill>
-                <a:latin typeface="Calibri"/>
-              </a:rPr>
-              <a:t>ignore sunk costs when choosing what to do next</a:t>
-            </a:r>
-          </a:p>
-        </p:txBody>
-      </p:sp>
-      <p:sp>
-        <p:nvSpPr>
-          <p:cNvPr id="13" name="TextBox 12"/>
-          <p:cNvSpPr txBox="1"/>
-          <p:nvPr/>
-        </p:nvSpPr>
-        <p:spPr>
-          <a:xfrm>
-            <a:off x="251999" y="4206240"/>
-            <a:ext cx="2926080" cy="868680"/>
-          </a:xfrm>
-          <a:prstGeom prst="rect">
-            <a:avLst/>
-          </a:prstGeom>
-          <a:noFill/>
-        </p:spPr>
-        <p:txBody>
-          <a:bodyPr wrap="square">
-            <a:spAutoFit/>
-          </a:bodyPr>
-          <a:lstStyle/>
-          <a:p>
-            <a:pPr algn="l"/>
-            <a:r>
-              <a:rPr sz="1800" b="1" i="0">
-                <a:solidFill>
-                  <a:srgbClr val="0B2B4E"/>
-                </a:solidFill>
-                <a:latin typeface="Calibri"/>
-              </a:rPr>
-              <a:t>Variable costs</a:t>
-            </a:r>
-          </a:p>
-        </p:txBody>
-      </p:sp>
-      <p:sp>
-        <p:nvSpPr>
-          <p:cNvPr id="14" name="TextBox 13"/>
-          <p:cNvSpPr txBox="1"/>
-          <p:nvPr/>
-        </p:nvSpPr>
-        <p:spPr>
-          <a:xfrm>
-            <a:off x="3360959" y="4206240"/>
-            <a:ext cx="8578737" cy="868680"/>
-          </a:xfrm>
-          <a:prstGeom prst="rect">
-            <a:avLst/>
-          </a:prstGeom>
-          <a:noFill/>
-        </p:spPr>
-        <p:txBody>
-          <a:bodyPr wrap="square">
-            <a:spAutoFit/>
-          </a:bodyPr>
-          <a:lstStyle/>
-          <a:p>
-            <a:pPr algn="l"/>
-            <a:r>
-              <a:rPr sz="1800" b="0" i="0">
-                <a:solidFill>
-                  <a:srgbClr val="555B66"/>
-                </a:solidFill>
-                <a:latin typeface="Calibri"/>
-              </a:rPr>
-              <a:t>depend on volume produced (Q)</a:t>
-            </a:r>
-          </a:p>
-        </p:txBody>
-      </p:sp>
-      <p:sp>
-        <p:nvSpPr>
-          <p:cNvPr id="15" name="Rectangle 14"/>
+              <a:t>Scale &amp; Scope</a:t>
+            </a:r>
+          </a:p>
+        </p:txBody>
+      </p:sp>
+      <p:sp>
+        <p:nvSpPr>
+          <p:cNvPr id="11" name="Rectangle 10"/>
           <p:cNvSpPr/>
           <p:nvPr/>
         </p:nvSpPr>
@@ -3616,7 +3825,7 @@
       </p:sp>
       <p:sp>
         <p:nvSpPr>
-          <p:cNvPr id="16" name="Rectangle 15"/>
+          <p:cNvPr id="12" name="Rectangle 11"/>
           <p:cNvSpPr/>
           <p:nvPr/>
         </p:nvSpPr>
@@ -3660,7 +3869,7 @@
       </p:sp>
       <p:sp>
         <p:nvSpPr>
-          <p:cNvPr id="17" name="TextBox 16"/>
+          <p:cNvPr id="13" name="TextBox 12"/>
           <p:cNvSpPr txBox="1"/>
           <p:nvPr/>
         </p:nvSpPr>
@@ -3675,7 +3884,7 @@
           <a:noFill/>
         </p:spPr>
         <p:txBody>
-          <a:bodyPr wrap="square">
+          <a:bodyPr wrap="square" lIns="0" rIns="0" tIns="0" bIns="0">
             <a:spAutoFit/>
           </a:bodyPr>
           <a:lstStyle/>
@@ -3695,6 +3904,1146 @@
       </p:sp>
       <p:sp>
         <p:nvSpPr>
+          <p:cNvPr id="14" name="TextBox 13"/>
+          <p:cNvSpPr txBox="1"/>
+          <p:nvPr/>
+        </p:nvSpPr>
+        <p:spPr>
+          <a:xfrm>
+            <a:off x="11521440" y="6601968"/>
+            <a:ext cx="457200" cy="274320"/>
+          </a:xfrm>
+          <a:prstGeom prst="rect">
+            <a:avLst/>
+          </a:prstGeom>
+          <a:noFill/>
+        </p:spPr>
+        <p:txBody>
+          <a:bodyPr wrap="square" lIns="0" rIns="0" tIns="0" bIns="0">
+            <a:spAutoFit/>
+          </a:bodyPr>
+          <a:lstStyle/>
+          <a:p>
+            <a:pPr algn="r"/>
+            <a:r>
+              <a:rPr sz="1000" b="0" i="0">
+                <a:solidFill>
+                  <a:srgbClr val="555B66"/>
+                </a:solidFill>
+                <a:latin typeface="Calibri"/>
+              </a:rPr>
+              <a:t>6</a:t>
+            </a:r>
+          </a:p>
+        </p:txBody>
+      </p:sp>
+    </p:spTree>
+  </p:cSld>
+  <p:clrMapOvr>
+    <a:masterClrMapping/>
+  </p:clrMapOvr>
+</p:sld>
+</file>
+
+<file path=ppt/slides/slide3.xml><?xml version="1.0" encoding="utf-8"?>
+<p:sld xmlns:a="http://schemas.openxmlformats.org/drawingml/2006/main" xmlns:p="http://schemas.openxmlformats.org/presentationml/2006/main" xmlns:r="http://schemas.openxmlformats.org/officeDocument/2006/relationships">
+  <p:cSld>
+    <p:spTree>
+      <p:nvGrpSpPr>
+        <p:cNvPr id="1" name=""/>
+        <p:cNvGrpSpPr/>
+        <p:nvPr/>
+      </p:nvGrpSpPr>
+      <p:grpSpPr/>
+      <p:sp>
+        <p:nvSpPr>
+          <p:cNvPr id="2" name="Rectangle 1"/>
+          <p:cNvSpPr/>
+          <p:nvPr/>
+        </p:nvSpPr>
+        <p:spPr>
+          <a:xfrm>
+            <a:off x="0" y="0"/>
+            <a:ext cx="12191695" cy="310896"/>
+          </a:xfrm>
+          <a:prstGeom prst="rect">
+            <a:avLst/>
+          </a:prstGeom>
+          <a:solidFill>
+            <a:srgbClr val="0B2B4E"/>
+          </a:solidFill>
+          <a:ln>
+            <a:noFill/>
+          </a:ln>
+          <a:effectLst/>
+        </p:spPr>
+        <p:style>
+          <a:lnRef idx="1">
+            <a:schemeClr val="accent1"/>
+          </a:lnRef>
+          <a:fillRef idx="3">
+            <a:schemeClr val="accent1"/>
+          </a:fillRef>
+          <a:effectRef idx="2">
+            <a:schemeClr val="accent1"/>
+          </a:effectRef>
+          <a:fontRef idx="minor">
+            <a:schemeClr val="lt1"/>
+          </a:fontRef>
+        </p:style>
+        <p:txBody>
+          <a:bodyPr rtlCol="0" anchor="ctr"/>
+          <a:lstStyle/>
+          <a:p>
+            <a:pPr algn="ctr"/>
+          </a:p>
+        </p:txBody>
+      </p:sp>
+      <p:sp>
+        <p:nvSpPr>
+          <p:cNvPr id="3" name="TextBox 2"/>
+          <p:cNvSpPr txBox="1"/>
+          <p:nvPr/>
+        </p:nvSpPr>
+        <p:spPr>
+          <a:xfrm>
+            <a:off x="251999" y="0"/>
+            <a:ext cx="10972800" cy="310896"/>
+          </a:xfrm>
+          <a:prstGeom prst="rect">
+            <a:avLst/>
+          </a:prstGeom>
+          <a:noFill/>
+        </p:spPr>
+        <p:txBody>
+          <a:bodyPr wrap="square" lIns="0" rIns="0" tIns="0" bIns="0" anchor="ctr">
+            <a:spAutoFit/>
+          </a:bodyPr>
+          <a:lstStyle/>
+          <a:p>
+            <a:pPr algn="l"/>
+            <a:r>
+              <a:rPr sz="1100" b="1" i="0">
+                <a:solidFill>
+                  <a:srgbClr val="FFFFFF"/>
+                </a:solidFill>
+                <a:latin typeface="Calibri"/>
+              </a:rPr>
+              <a:t>MODULE 3 · PART 1 · PRODUCTION</a:t>
+            </a:r>
+          </a:p>
+        </p:txBody>
+      </p:sp>
+      <p:sp>
+        <p:nvSpPr>
+          <p:cNvPr id="4" name="TextBox 3"/>
+          <p:cNvSpPr txBox="1"/>
+          <p:nvPr/>
+        </p:nvSpPr>
+        <p:spPr>
+          <a:xfrm>
+            <a:off x="251999" y="502920"/>
+            <a:ext cx="11687697" cy="640080"/>
+          </a:xfrm>
+          <a:prstGeom prst="rect">
+            <a:avLst/>
+          </a:prstGeom>
+          <a:noFill/>
+        </p:spPr>
+        <p:txBody>
+          <a:bodyPr wrap="square" lIns="0" rIns="0" tIns="0" bIns="0">
+            <a:spAutoFit/>
+          </a:bodyPr>
+          <a:lstStyle/>
+          <a:p>
+            <a:pPr algn="l"/>
+            <a:r>
+              <a:rPr sz="3200" b="1" i="0">
+                <a:solidFill>
+                  <a:srgbClr val="0B2B4E"/>
+                </a:solidFill>
+                <a:latin typeface="Calibri"/>
+              </a:rPr>
+              <a:t>Hire when MRPL &gt; wage; stop when MRPL = wage</a:t>
+            </a:r>
+          </a:p>
+        </p:txBody>
+      </p:sp>
+      <p:sp>
+        <p:nvSpPr>
+          <p:cNvPr id="5" name="Rectangle 4"/>
+          <p:cNvSpPr/>
+          <p:nvPr/>
+        </p:nvSpPr>
+        <p:spPr>
+          <a:xfrm>
+            <a:off x="251999" y="1143000"/>
+            <a:ext cx="11687697" cy="18288"/>
+          </a:xfrm>
+          <a:prstGeom prst="rect">
+            <a:avLst/>
+          </a:prstGeom>
+          <a:solidFill>
+            <a:srgbClr val="C8CDD3"/>
+          </a:solidFill>
+          <a:ln>
+            <a:noFill/>
+          </a:ln>
+          <a:effectLst/>
+        </p:spPr>
+        <p:style>
+          <a:lnRef idx="1">
+            <a:schemeClr val="accent1"/>
+          </a:lnRef>
+          <a:fillRef idx="3">
+            <a:schemeClr val="accent1"/>
+          </a:fillRef>
+          <a:effectRef idx="2">
+            <a:schemeClr val="accent1"/>
+          </a:effectRef>
+          <a:fontRef idx="minor">
+            <a:schemeClr val="lt1"/>
+          </a:fontRef>
+        </p:style>
+        <p:txBody>
+          <a:bodyPr rtlCol="0" anchor="ctr"/>
+          <a:lstStyle/>
+          <a:p>
+            <a:pPr algn="ctr"/>
+          </a:p>
+        </p:txBody>
+      </p:sp>
+      <p:sp>
+        <p:nvSpPr>
+          <p:cNvPr id="6" name="Rectangle 5"/>
+          <p:cNvSpPr/>
+          <p:nvPr/>
+        </p:nvSpPr>
+        <p:spPr>
+          <a:xfrm>
+            <a:off x="251999" y="1129284"/>
+            <a:ext cx="2011680" cy="45720"/>
+          </a:xfrm>
+          <a:prstGeom prst="rect">
+            <a:avLst/>
+          </a:prstGeom>
+          <a:solidFill>
+            <a:srgbClr val="E09F3E"/>
+          </a:solidFill>
+          <a:ln>
+            <a:noFill/>
+          </a:ln>
+          <a:effectLst/>
+        </p:spPr>
+        <p:style>
+          <a:lnRef idx="1">
+            <a:schemeClr val="accent1"/>
+          </a:lnRef>
+          <a:fillRef idx="3">
+            <a:schemeClr val="accent1"/>
+          </a:fillRef>
+          <a:effectRef idx="2">
+            <a:schemeClr val="accent1"/>
+          </a:effectRef>
+          <a:fontRef idx="minor">
+            <a:schemeClr val="lt1"/>
+          </a:fontRef>
+        </p:style>
+        <p:txBody>
+          <a:bodyPr rtlCol="0" anchor="ctr"/>
+          <a:lstStyle/>
+          <a:p>
+            <a:pPr algn="ctr"/>
+          </a:p>
+        </p:txBody>
+      </p:sp>
+      <p:sp>
+        <p:nvSpPr>
+          <p:cNvPr id="7" name="TextBox 6"/>
+          <p:cNvSpPr txBox="1"/>
+          <p:nvPr/>
+        </p:nvSpPr>
+        <p:spPr>
+          <a:xfrm>
+            <a:off x="251999" y="1691640"/>
+            <a:ext cx="11687697" cy="4572000"/>
+          </a:xfrm>
+          <a:prstGeom prst="rect">
+            <a:avLst/>
+          </a:prstGeom>
+          <a:noFill/>
+        </p:spPr>
+        <p:txBody>
+          <a:bodyPr wrap="square" lIns="0" rIns="0" tIns="0" bIns="0">
+            <a:spAutoFit/>
+          </a:bodyPr>
+          <a:lstStyle/>
+          <a:p>
+            <a:pPr algn="l" marL="342900" indent="-342900">
+              <a:buClr>
+                <a:srgbClr val="0B2B4E"/>
+              </a:buClr>
+              <a:buFont typeface="Calibri"/>
+              <a:buChar char="▪"/>
+            </a:pPr>
+            <a:r>
+              <a:rPr sz="2400" b="0">
+                <a:solidFill>
+                  <a:srgbClr val="0B2B4E"/>
+                </a:solidFill>
+                <a:latin typeface="Calibri"/>
+              </a:rPr>
+              <a:t>Add a worker → output rises by MPL</a:t>
+            </a:r>
+          </a:p>
+          <a:p>
+            <a:pPr algn="l" marL="342900" indent="-342900">
+              <a:spcBef>
+                <a:spcPts val="1800"/>
+              </a:spcBef>
+              <a:buClr>
+                <a:srgbClr val="0B2B4E"/>
+              </a:buClr>
+              <a:buFont typeface="Calibri"/>
+              <a:buChar char="▪"/>
+            </a:pPr>
+            <a:r>
+              <a:rPr sz="2400" b="0">
+                <a:solidFill>
+                  <a:srgbClr val="0B2B4E"/>
+                </a:solidFill>
+                <a:latin typeface="Calibri"/>
+              </a:rPr>
+              <a:t>Revenue from that worker = MRPL = MPL × price</a:t>
+            </a:r>
+          </a:p>
+          <a:p>
+            <a:pPr algn="l" marL="342900" indent="-342900">
+              <a:spcBef>
+                <a:spcPts val="1800"/>
+              </a:spcBef>
+              <a:buClr>
+                <a:srgbClr val="0B2B4E"/>
+              </a:buClr>
+              <a:buFont typeface="Calibri"/>
+              <a:buChar char="▪"/>
+            </a:pPr>
+            <a:r>
+              <a:rPr sz="2400" b="0">
+                <a:solidFill>
+                  <a:srgbClr val="0B2B4E"/>
+                </a:solidFill>
+                <a:latin typeface="Calibri"/>
+              </a:rPr>
+              <a:t>Hire if MRPL &gt; wage; the next dollar earns more than it costs</a:t>
+            </a:r>
+          </a:p>
+          <a:p>
+            <a:pPr algn="l" marL="342900" indent="-342900">
+              <a:spcBef>
+                <a:spcPts val="1800"/>
+              </a:spcBef>
+              <a:buClr>
+                <a:srgbClr val="0B2B4E"/>
+              </a:buClr>
+              <a:buFont typeface="Calibri"/>
+              <a:buChar char="▪"/>
+            </a:pPr>
+            <a:r>
+              <a:rPr sz="2400" b="0">
+                <a:solidFill>
+                  <a:srgbClr val="0B2B4E"/>
+                </a:solidFill>
+                <a:latin typeface="Calibri"/>
+              </a:rPr>
+              <a:t>Stop when MRPL = wage – the marginal hire just breaks even</a:t>
+            </a:r>
+          </a:p>
+        </p:txBody>
+      </p:sp>
+      <p:sp>
+        <p:nvSpPr>
+          <p:cNvPr id="8" name="Rectangle 7"/>
+          <p:cNvSpPr/>
+          <p:nvPr/>
+        </p:nvSpPr>
+        <p:spPr>
+          <a:xfrm>
+            <a:off x="0" y="6537960"/>
+            <a:ext cx="12191695" cy="18288"/>
+          </a:xfrm>
+          <a:prstGeom prst="rect">
+            <a:avLst/>
+          </a:prstGeom>
+          <a:solidFill>
+            <a:srgbClr val="C8CDD3"/>
+          </a:solidFill>
+          <a:ln>
+            <a:noFill/>
+          </a:ln>
+          <a:effectLst/>
+        </p:spPr>
+        <p:style>
+          <a:lnRef idx="1">
+            <a:schemeClr val="accent1"/>
+          </a:lnRef>
+          <a:fillRef idx="3">
+            <a:schemeClr val="accent1"/>
+          </a:fillRef>
+          <a:effectRef idx="2">
+            <a:schemeClr val="accent1"/>
+          </a:effectRef>
+          <a:fontRef idx="minor">
+            <a:schemeClr val="lt1"/>
+          </a:fontRef>
+        </p:style>
+        <p:txBody>
+          <a:bodyPr rtlCol="0" anchor="ctr"/>
+          <a:lstStyle/>
+          <a:p>
+            <a:pPr algn="ctr"/>
+          </a:p>
+        </p:txBody>
+      </p:sp>
+      <p:sp>
+        <p:nvSpPr>
+          <p:cNvPr id="9" name="Rectangle 8"/>
+          <p:cNvSpPr/>
+          <p:nvPr/>
+        </p:nvSpPr>
+        <p:spPr>
+          <a:xfrm>
+            <a:off x="251999" y="6524244"/>
+            <a:ext cx="2011680" cy="45720"/>
+          </a:xfrm>
+          <a:prstGeom prst="rect">
+            <a:avLst/>
+          </a:prstGeom>
+          <a:solidFill>
+            <a:srgbClr val="E09F3E"/>
+          </a:solidFill>
+          <a:ln>
+            <a:noFill/>
+          </a:ln>
+          <a:effectLst/>
+        </p:spPr>
+        <p:style>
+          <a:lnRef idx="1">
+            <a:schemeClr val="accent1"/>
+          </a:lnRef>
+          <a:fillRef idx="3">
+            <a:schemeClr val="accent1"/>
+          </a:fillRef>
+          <a:effectRef idx="2">
+            <a:schemeClr val="accent1"/>
+          </a:effectRef>
+          <a:fontRef idx="minor">
+            <a:schemeClr val="lt1"/>
+          </a:fontRef>
+        </p:style>
+        <p:txBody>
+          <a:bodyPr rtlCol="0" anchor="ctr"/>
+          <a:lstStyle/>
+          <a:p>
+            <a:pPr algn="ctr"/>
+          </a:p>
+        </p:txBody>
+      </p:sp>
+      <p:sp>
+        <p:nvSpPr>
+          <p:cNvPr id="10" name="TextBox 9"/>
+          <p:cNvSpPr txBox="1"/>
+          <p:nvPr/>
+        </p:nvSpPr>
+        <p:spPr>
+          <a:xfrm>
+            <a:off x="251999" y="6601968"/>
+            <a:ext cx="10058400" cy="274320"/>
+          </a:xfrm>
+          <a:prstGeom prst="rect">
+            <a:avLst/>
+          </a:prstGeom>
+          <a:noFill/>
+        </p:spPr>
+        <p:txBody>
+          <a:bodyPr wrap="square" lIns="0" rIns="0" tIns="0" bIns="0">
+            <a:spAutoFit/>
+          </a:bodyPr>
+          <a:lstStyle/>
+          <a:p>
+            <a:pPr algn="l"/>
+            <a:r>
+              <a:rPr sz="1000" b="0" i="0">
+                <a:solidFill>
+                  <a:srgbClr val="555B66"/>
+                </a:solidFill>
+                <a:latin typeface="Calibri"/>
+              </a:rPr>
+              <a:t>Management 405  ·  Module 3  ·  Production and Costs</a:t>
+            </a:r>
+          </a:p>
+        </p:txBody>
+      </p:sp>
+      <p:sp>
+        <p:nvSpPr>
+          <p:cNvPr id="11" name="TextBox 10"/>
+          <p:cNvSpPr txBox="1"/>
+          <p:nvPr/>
+        </p:nvSpPr>
+        <p:spPr>
+          <a:xfrm>
+            <a:off x="11521440" y="6601968"/>
+            <a:ext cx="457200" cy="274320"/>
+          </a:xfrm>
+          <a:prstGeom prst="rect">
+            <a:avLst/>
+          </a:prstGeom>
+          <a:noFill/>
+        </p:spPr>
+        <p:txBody>
+          <a:bodyPr wrap="square" lIns="0" rIns="0" tIns="0" bIns="0">
+            <a:spAutoFit/>
+          </a:bodyPr>
+          <a:lstStyle/>
+          <a:p>
+            <a:pPr algn="r"/>
+            <a:r>
+              <a:rPr sz="1000" b="0" i="0">
+                <a:solidFill>
+                  <a:srgbClr val="555B66"/>
+                </a:solidFill>
+                <a:latin typeface="Calibri"/>
+              </a:rPr>
+              <a:t>21</a:t>
+            </a:r>
+          </a:p>
+        </p:txBody>
+      </p:sp>
+    </p:spTree>
+  </p:cSld>
+  <p:clrMapOvr>
+    <a:masterClrMapping/>
+  </p:clrMapOvr>
+</p:sld>
+</file>
+
+<file path=ppt/slides/slide4.xml><?xml version="1.0" encoding="utf-8"?>
+<p:sld xmlns:a="http://schemas.openxmlformats.org/drawingml/2006/main" xmlns:p="http://schemas.openxmlformats.org/presentationml/2006/main" xmlns:r="http://schemas.openxmlformats.org/officeDocument/2006/relationships">
+  <p:cSld>
+    <p:spTree>
+      <p:nvGrpSpPr>
+        <p:cNvPr id="1" name=""/>
+        <p:cNvGrpSpPr/>
+        <p:nvPr/>
+      </p:nvGrpSpPr>
+      <p:grpSpPr/>
+      <p:sp>
+        <p:nvSpPr>
+          <p:cNvPr id="2" name="Rectangle 1"/>
+          <p:cNvSpPr/>
+          <p:nvPr/>
+        </p:nvSpPr>
+        <p:spPr>
+          <a:xfrm>
+            <a:off x="0" y="0"/>
+            <a:ext cx="12191695" cy="310896"/>
+          </a:xfrm>
+          <a:prstGeom prst="rect">
+            <a:avLst/>
+          </a:prstGeom>
+          <a:solidFill>
+            <a:srgbClr val="0B2B4E"/>
+          </a:solidFill>
+          <a:ln>
+            <a:noFill/>
+          </a:ln>
+          <a:effectLst/>
+        </p:spPr>
+        <p:style>
+          <a:lnRef idx="1">
+            <a:schemeClr val="accent1"/>
+          </a:lnRef>
+          <a:fillRef idx="3">
+            <a:schemeClr val="accent1"/>
+          </a:fillRef>
+          <a:effectRef idx="2">
+            <a:schemeClr val="accent1"/>
+          </a:effectRef>
+          <a:fontRef idx="minor">
+            <a:schemeClr val="lt1"/>
+          </a:fontRef>
+        </p:style>
+        <p:txBody>
+          <a:bodyPr rtlCol="0" anchor="ctr"/>
+          <a:lstStyle/>
+          <a:p>
+            <a:pPr algn="ctr"/>
+          </a:p>
+        </p:txBody>
+      </p:sp>
+      <p:sp>
+        <p:nvSpPr>
+          <p:cNvPr id="3" name="TextBox 2"/>
+          <p:cNvSpPr txBox="1"/>
+          <p:nvPr/>
+        </p:nvSpPr>
+        <p:spPr>
+          <a:xfrm>
+            <a:off x="251999" y="0"/>
+            <a:ext cx="10972800" cy="310896"/>
+          </a:xfrm>
+          <a:prstGeom prst="rect">
+            <a:avLst/>
+          </a:prstGeom>
+          <a:noFill/>
+        </p:spPr>
+        <p:txBody>
+          <a:bodyPr wrap="square" lIns="0" rIns="0" tIns="0" bIns="0" anchor="ctr">
+            <a:spAutoFit/>
+          </a:bodyPr>
+          <a:lstStyle/>
+          <a:p>
+            <a:pPr algn="l"/>
+            <a:r>
+              <a:rPr sz="1100" b="1" i="0">
+                <a:solidFill>
+                  <a:srgbClr val="FFFFFF"/>
+                </a:solidFill>
+                <a:latin typeface="Calibri"/>
+              </a:rPr>
+              <a:t>MODULE 3 · PART 2 · COSTS</a:t>
+            </a:r>
+          </a:p>
+        </p:txBody>
+      </p:sp>
+      <p:sp>
+        <p:nvSpPr>
+          <p:cNvPr id="4" name="TextBox 3"/>
+          <p:cNvSpPr txBox="1"/>
+          <p:nvPr/>
+        </p:nvSpPr>
+        <p:spPr>
+          <a:xfrm>
+            <a:off x="251999" y="502920"/>
+            <a:ext cx="11687697" cy="640080"/>
+          </a:xfrm>
+          <a:prstGeom prst="rect">
+            <a:avLst/>
+          </a:prstGeom>
+          <a:noFill/>
+        </p:spPr>
+        <p:txBody>
+          <a:bodyPr wrap="square" lIns="0" rIns="0" tIns="0" bIns="0">
+            <a:spAutoFit/>
+          </a:bodyPr>
+          <a:lstStyle/>
+          <a:p>
+            <a:pPr algn="l"/>
+            <a:r>
+              <a:rPr sz="3200" b="1" i="0">
+                <a:solidFill>
+                  <a:srgbClr val="0B2B4E"/>
+                </a:solidFill>
+                <a:latin typeface="Calibri"/>
+              </a:rPr>
+              <a:t>Sunk costs should never drive decisions</a:t>
+            </a:r>
+          </a:p>
+        </p:txBody>
+      </p:sp>
+      <p:sp>
+        <p:nvSpPr>
+          <p:cNvPr id="5" name="Rectangle 4"/>
+          <p:cNvSpPr/>
+          <p:nvPr/>
+        </p:nvSpPr>
+        <p:spPr>
+          <a:xfrm>
+            <a:off x="251999" y="1143000"/>
+            <a:ext cx="11687697" cy="18288"/>
+          </a:xfrm>
+          <a:prstGeom prst="rect">
+            <a:avLst/>
+          </a:prstGeom>
+          <a:solidFill>
+            <a:srgbClr val="C8CDD3"/>
+          </a:solidFill>
+          <a:ln>
+            <a:noFill/>
+          </a:ln>
+          <a:effectLst/>
+        </p:spPr>
+        <p:style>
+          <a:lnRef idx="1">
+            <a:schemeClr val="accent1"/>
+          </a:lnRef>
+          <a:fillRef idx="3">
+            <a:schemeClr val="accent1"/>
+          </a:fillRef>
+          <a:effectRef idx="2">
+            <a:schemeClr val="accent1"/>
+          </a:effectRef>
+          <a:fontRef idx="minor">
+            <a:schemeClr val="lt1"/>
+          </a:fontRef>
+        </p:style>
+        <p:txBody>
+          <a:bodyPr rtlCol="0" anchor="ctr"/>
+          <a:lstStyle/>
+          <a:p>
+            <a:pPr algn="ctr"/>
+          </a:p>
+        </p:txBody>
+      </p:sp>
+      <p:sp>
+        <p:nvSpPr>
+          <p:cNvPr id="6" name="Rectangle 5"/>
+          <p:cNvSpPr/>
+          <p:nvPr/>
+        </p:nvSpPr>
+        <p:spPr>
+          <a:xfrm>
+            <a:off x="251999" y="1129284"/>
+            <a:ext cx="2011680" cy="45720"/>
+          </a:xfrm>
+          <a:prstGeom prst="rect">
+            <a:avLst/>
+          </a:prstGeom>
+          <a:solidFill>
+            <a:srgbClr val="E09F3E"/>
+          </a:solidFill>
+          <a:ln>
+            <a:noFill/>
+          </a:ln>
+          <a:effectLst/>
+        </p:spPr>
+        <p:style>
+          <a:lnRef idx="1">
+            <a:schemeClr val="accent1"/>
+          </a:lnRef>
+          <a:fillRef idx="3">
+            <a:schemeClr val="accent1"/>
+          </a:fillRef>
+          <a:effectRef idx="2">
+            <a:schemeClr val="accent1"/>
+          </a:effectRef>
+          <a:fontRef idx="minor">
+            <a:schemeClr val="lt1"/>
+          </a:fontRef>
+        </p:style>
+        <p:txBody>
+          <a:bodyPr rtlCol="0" anchor="ctr"/>
+          <a:lstStyle/>
+          <a:p>
+            <a:pPr algn="ctr"/>
+          </a:p>
+        </p:txBody>
+      </p:sp>
+      <p:sp>
+        <p:nvSpPr>
+          <p:cNvPr id="7" name="TextBox 6"/>
+          <p:cNvSpPr txBox="1"/>
+          <p:nvPr/>
+        </p:nvSpPr>
+        <p:spPr>
+          <a:xfrm>
+            <a:off x="251999" y="1783080"/>
+            <a:ext cx="2926080" cy="868680"/>
+          </a:xfrm>
+          <a:prstGeom prst="rect">
+            <a:avLst/>
+          </a:prstGeom>
+          <a:noFill/>
+        </p:spPr>
+        <p:txBody>
+          <a:bodyPr wrap="square" lIns="0" rIns="0" tIns="0" bIns="0">
+            <a:spAutoFit/>
+          </a:bodyPr>
+          <a:lstStyle/>
+          <a:p>
+            <a:pPr algn="l"/>
+            <a:r>
+              <a:rPr sz="1800" b="1" i="0">
+                <a:solidFill>
+                  <a:srgbClr val="0B2B4E"/>
+                </a:solidFill>
+                <a:latin typeface="Calibri"/>
+              </a:rPr>
+              <a:t>Fixed costs</a:t>
+            </a:r>
+          </a:p>
+        </p:txBody>
+      </p:sp>
+      <p:sp>
+        <p:nvSpPr>
+          <p:cNvPr id="8" name="TextBox 7"/>
+          <p:cNvSpPr txBox="1"/>
+          <p:nvPr/>
+        </p:nvSpPr>
+        <p:spPr>
+          <a:xfrm>
+            <a:off x="3360959" y="1783080"/>
+            <a:ext cx="8578737" cy="868680"/>
+          </a:xfrm>
+          <a:prstGeom prst="rect">
+            <a:avLst/>
+          </a:prstGeom>
+          <a:noFill/>
+        </p:spPr>
+        <p:txBody>
+          <a:bodyPr wrap="square" lIns="0" rIns="0" tIns="0" bIns="0">
+            <a:spAutoFit/>
+          </a:bodyPr>
+          <a:lstStyle/>
+          <a:p>
+            <a:pPr algn="l"/>
+            <a:r>
+              <a:rPr sz="1800" b="0" i="0">
+                <a:solidFill>
+                  <a:srgbClr val="555B66"/>
+                </a:solidFill>
+                <a:latin typeface="Calibri"/>
+              </a:rPr>
+              <a:t>don't depend on quantity produced (Q)</a:t>
+            </a:r>
+          </a:p>
+        </p:txBody>
+      </p:sp>
+      <p:sp>
+        <p:nvSpPr>
+          <p:cNvPr id="9" name="TextBox 8"/>
+          <p:cNvSpPr txBox="1"/>
+          <p:nvPr/>
+        </p:nvSpPr>
+        <p:spPr>
+          <a:xfrm>
+            <a:off x="251999" y="2651760"/>
+            <a:ext cx="2926080" cy="868680"/>
+          </a:xfrm>
+          <a:prstGeom prst="rect">
+            <a:avLst/>
+          </a:prstGeom>
+          <a:noFill/>
+        </p:spPr>
+        <p:txBody>
+          <a:bodyPr wrap="square" lIns="0" rIns="0" tIns="0" bIns="0">
+            <a:spAutoFit/>
+          </a:bodyPr>
+          <a:lstStyle/>
+          <a:p>
+            <a:pPr algn="l"/>
+            <a:r>
+              <a:rPr sz="1800" b="1" i="0">
+                <a:solidFill>
+                  <a:srgbClr val="0B2B4E"/>
+                </a:solidFill>
+                <a:latin typeface="Calibri"/>
+              </a:rPr>
+              <a:t>Sunk costs</a:t>
+            </a:r>
+          </a:p>
+        </p:txBody>
+      </p:sp>
+      <p:sp>
+        <p:nvSpPr>
+          <p:cNvPr id="10" name="TextBox 9"/>
+          <p:cNvSpPr txBox="1"/>
+          <p:nvPr/>
+        </p:nvSpPr>
+        <p:spPr>
+          <a:xfrm>
+            <a:off x="3360959" y="2651760"/>
+            <a:ext cx="8578737" cy="868680"/>
+          </a:xfrm>
+          <a:prstGeom prst="rect">
+            <a:avLst/>
+          </a:prstGeom>
+          <a:noFill/>
+        </p:spPr>
+        <p:txBody>
+          <a:bodyPr wrap="square" lIns="0" rIns="0" tIns="0" bIns="0">
+            <a:spAutoFit/>
+          </a:bodyPr>
+          <a:lstStyle/>
+          <a:p>
+            <a:pPr algn="l"/>
+            <a:r>
+              <a:rPr sz="1800" b="0" i="0">
+                <a:solidFill>
+                  <a:srgbClr val="555B66"/>
+                </a:solidFill>
+                <a:latin typeface="Calibri"/>
+              </a:rPr>
+              <a:t>a fixed cost that cannot be recovered</a:t>
+            </a:r>
+          </a:p>
+        </p:txBody>
+      </p:sp>
+      <p:sp>
+        <p:nvSpPr>
+          <p:cNvPr id="11" name="TextBox 10"/>
+          <p:cNvSpPr txBox="1"/>
+          <p:nvPr/>
+        </p:nvSpPr>
+        <p:spPr>
+          <a:xfrm>
+            <a:off x="251999" y="3520440"/>
+            <a:ext cx="2926080" cy="868680"/>
+          </a:xfrm>
+          <a:prstGeom prst="rect">
+            <a:avLst/>
+          </a:prstGeom>
+          <a:noFill/>
+        </p:spPr>
+        <p:txBody>
+          <a:bodyPr wrap="square" lIns="0" rIns="0" tIns="0" bIns="0">
+            <a:spAutoFit/>
+          </a:bodyPr>
+          <a:lstStyle/>
+          <a:p>
+            <a:pPr algn="l"/>
+            <a:r>
+              <a:rPr sz="1800" b="1" i="0">
+                <a:solidFill>
+                  <a:srgbClr val="0B2B4E"/>
+                </a:solidFill>
+                <a:latin typeface="Calibri"/>
+              </a:rPr>
+              <a:t>→ Decision rule</a:t>
+            </a:r>
+          </a:p>
+        </p:txBody>
+      </p:sp>
+      <p:sp>
+        <p:nvSpPr>
+          <p:cNvPr id="12" name="TextBox 11"/>
+          <p:cNvSpPr txBox="1"/>
+          <p:nvPr/>
+        </p:nvSpPr>
+        <p:spPr>
+          <a:xfrm>
+            <a:off x="3360959" y="3520440"/>
+            <a:ext cx="8578737" cy="868680"/>
+          </a:xfrm>
+          <a:prstGeom prst="rect">
+            <a:avLst/>
+          </a:prstGeom>
+          <a:noFill/>
+        </p:spPr>
+        <p:txBody>
+          <a:bodyPr wrap="square" lIns="0" rIns="0" tIns="0" bIns="0">
+            <a:spAutoFit/>
+          </a:bodyPr>
+          <a:lstStyle/>
+          <a:p>
+            <a:pPr algn="l"/>
+            <a:r>
+              <a:rPr sz="1800" b="0" i="0">
+                <a:solidFill>
+                  <a:srgbClr val="555B66"/>
+                </a:solidFill>
+                <a:latin typeface="Calibri"/>
+              </a:rPr>
+              <a:t>ignore sunk costs when choosing what to do next</a:t>
+            </a:r>
+          </a:p>
+        </p:txBody>
+      </p:sp>
+      <p:sp>
+        <p:nvSpPr>
+          <p:cNvPr id="13" name="TextBox 12"/>
+          <p:cNvSpPr txBox="1"/>
+          <p:nvPr/>
+        </p:nvSpPr>
+        <p:spPr>
+          <a:xfrm>
+            <a:off x="251999" y="4389120"/>
+            <a:ext cx="2926080" cy="868680"/>
+          </a:xfrm>
+          <a:prstGeom prst="rect">
+            <a:avLst/>
+          </a:prstGeom>
+          <a:noFill/>
+        </p:spPr>
+        <p:txBody>
+          <a:bodyPr wrap="square" lIns="0" rIns="0" tIns="0" bIns="0">
+            <a:spAutoFit/>
+          </a:bodyPr>
+          <a:lstStyle/>
+          <a:p>
+            <a:pPr algn="l"/>
+            <a:r>
+              <a:rPr sz="1800" b="1" i="0">
+                <a:solidFill>
+                  <a:srgbClr val="0B2B4E"/>
+                </a:solidFill>
+                <a:latin typeface="Calibri"/>
+              </a:rPr>
+              <a:t>Variable costs</a:t>
+            </a:r>
+          </a:p>
+        </p:txBody>
+      </p:sp>
+      <p:sp>
+        <p:nvSpPr>
+          <p:cNvPr id="14" name="TextBox 13"/>
+          <p:cNvSpPr txBox="1"/>
+          <p:nvPr/>
+        </p:nvSpPr>
+        <p:spPr>
+          <a:xfrm>
+            <a:off x="3360959" y="4389120"/>
+            <a:ext cx="8578737" cy="868680"/>
+          </a:xfrm>
+          <a:prstGeom prst="rect">
+            <a:avLst/>
+          </a:prstGeom>
+          <a:noFill/>
+        </p:spPr>
+        <p:txBody>
+          <a:bodyPr wrap="square" lIns="0" rIns="0" tIns="0" bIns="0">
+            <a:spAutoFit/>
+          </a:bodyPr>
+          <a:lstStyle/>
+          <a:p>
+            <a:pPr algn="l"/>
+            <a:r>
+              <a:rPr sz="1800" b="0" i="0">
+                <a:solidFill>
+                  <a:srgbClr val="555B66"/>
+                </a:solidFill>
+                <a:latin typeface="Calibri"/>
+              </a:rPr>
+              <a:t>depend on volume produced (Q)</a:t>
+            </a:r>
+          </a:p>
+        </p:txBody>
+      </p:sp>
+      <p:sp>
+        <p:nvSpPr>
+          <p:cNvPr id="15" name="Rectangle 14"/>
+          <p:cNvSpPr/>
+          <p:nvPr/>
+        </p:nvSpPr>
+        <p:spPr>
+          <a:xfrm>
+            <a:off x="0" y="6537960"/>
+            <a:ext cx="12191695" cy="18288"/>
+          </a:xfrm>
+          <a:prstGeom prst="rect">
+            <a:avLst/>
+          </a:prstGeom>
+          <a:solidFill>
+            <a:srgbClr val="C8CDD3"/>
+          </a:solidFill>
+          <a:ln>
+            <a:noFill/>
+          </a:ln>
+          <a:effectLst/>
+        </p:spPr>
+        <p:style>
+          <a:lnRef idx="1">
+            <a:schemeClr val="accent1"/>
+          </a:lnRef>
+          <a:fillRef idx="3">
+            <a:schemeClr val="accent1"/>
+          </a:fillRef>
+          <a:effectRef idx="2">
+            <a:schemeClr val="accent1"/>
+          </a:effectRef>
+          <a:fontRef idx="minor">
+            <a:schemeClr val="lt1"/>
+          </a:fontRef>
+        </p:style>
+        <p:txBody>
+          <a:bodyPr rtlCol="0" anchor="ctr"/>
+          <a:lstStyle/>
+          <a:p>
+            <a:pPr algn="ctr"/>
+          </a:p>
+        </p:txBody>
+      </p:sp>
+      <p:sp>
+        <p:nvSpPr>
+          <p:cNvPr id="16" name="Rectangle 15"/>
+          <p:cNvSpPr/>
+          <p:nvPr/>
+        </p:nvSpPr>
+        <p:spPr>
+          <a:xfrm>
+            <a:off x="251999" y="6524244"/>
+            <a:ext cx="2011680" cy="45720"/>
+          </a:xfrm>
+          <a:prstGeom prst="rect">
+            <a:avLst/>
+          </a:prstGeom>
+          <a:solidFill>
+            <a:srgbClr val="E09F3E"/>
+          </a:solidFill>
+          <a:ln>
+            <a:noFill/>
+          </a:ln>
+          <a:effectLst/>
+        </p:spPr>
+        <p:style>
+          <a:lnRef idx="1">
+            <a:schemeClr val="accent1"/>
+          </a:lnRef>
+          <a:fillRef idx="3">
+            <a:schemeClr val="accent1"/>
+          </a:fillRef>
+          <a:effectRef idx="2">
+            <a:schemeClr val="accent1"/>
+          </a:effectRef>
+          <a:fontRef idx="minor">
+            <a:schemeClr val="lt1"/>
+          </a:fontRef>
+        </p:style>
+        <p:txBody>
+          <a:bodyPr rtlCol="0" anchor="ctr"/>
+          <a:lstStyle/>
+          <a:p>
+            <a:pPr algn="ctr"/>
+          </a:p>
+        </p:txBody>
+      </p:sp>
+      <p:sp>
+        <p:nvSpPr>
+          <p:cNvPr id="17" name="TextBox 16"/>
+          <p:cNvSpPr txBox="1"/>
+          <p:nvPr/>
+        </p:nvSpPr>
+        <p:spPr>
+          <a:xfrm>
+            <a:off x="251999" y="6601968"/>
+            <a:ext cx="10058400" cy="274320"/>
+          </a:xfrm>
+          <a:prstGeom prst="rect">
+            <a:avLst/>
+          </a:prstGeom>
+          <a:noFill/>
+        </p:spPr>
+        <p:txBody>
+          <a:bodyPr wrap="square" lIns="0" rIns="0" tIns="0" bIns="0">
+            <a:spAutoFit/>
+          </a:bodyPr>
+          <a:lstStyle/>
+          <a:p>
+            <a:pPr algn="l"/>
+            <a:r>
+              <a:rPr sz="1000" b="0" i="0">
+                <a:solidFill>
+                  <a:srgbClr val="555B66"/>
+                </a:solidFill>
+                <a:latin typeface="Calibri"/>
+              </a:rPr>
+              <a:t>Management 405  ·  Module 3  ·  Production and Costs</a:t>
+            </a:r>
+          </a:p>
+        </p:txBody>
+      </p:sp>
+      <p:sp>
+        <p:nvSpPr>
           <p:cNvPr id="18" name="TextBox 17"/>
           <p:cNvSpPr txBox="1"/>
           <p:nvPr/>
@@ -3710,7 +5059,7 @@
           <a:noFill/>
         </p:spPr>
         <p:txBody>
-          <a:bodyPr wrap="square">
+          <a:bodyPr wrap="square" lIns="0" rIns="0" tIns="0" bIns="0">
             <a:spAutoFit/>
           </a:bodyPr>
           <a:lstStyle/>
@@ -3723,7 +5072,1561 @@
                 </a:solidFill>
                 <a:latin typeface="Calibri"/>
               </a:rPr>
-              <a:t>1</a:t>
+              <a:t>42</a:t>
+            </a:r>
+          </a:p>
+        </p:txBody>
+      </p:sp>
+    </p:spTree>
+  </p:cSld>
+  <p:clrMapOvr>
+    <a:masterClrMapping/>
+  </p:clrMapOvr>
+</p:sld>
+</file>
+
+<file path=ppt/slides/slide5.xml><?xml version="1.0" encoding="utf-8"?>
+<p:sld xmlns:a="http://schemas.openxmlformats.org/drawingml/2006/main" xmlns:p="http://schemas.openxmlformats.org/presentationml/2006/main" xmlns:r="http://schemas.openxmlformats.org/officeDocument/2006/relationships">
+  <p:cSld>
+    <p:spTree>
+      <p:nvGrpSpPr>
+        <p:cNvPr id="1" name=""/>
+        <p:cNvGrpSpPr/>
+        <p:nvPr/>
+      </p:nvGrpSpPr>
+      <p:grpSpPr/>
+      <p:sp>
+        <p:nvSpPr>
+          <p:cNvPr id="2" name="Rectangle 1"/>
+          <p:cNvSpPr/>
+          <p:nvPr/>
+        </p:nvSpPr>
+        <p:spPr>
+          <a:xfrm>
+            <a:off x="0" y="0"/>
+            <a:ext cx="12191695" cy="310896"/>
+          </a:xfrm>
+          <a:prstGeom prst="rect">
+            <a:avLst/>
+          </a:prstGeom>
+          <a:solidFill>
+            <a:srgbClr val="0B2B4E"/>
+          </a:solidFill>
+          <a:ln>
+            <a:noFill/>
+          </a:ln>
+          <a:effectLst/>
+        </p:spPr>
+        <p:style>
+          <a:lnRef idx="1">
+            <a:schemeClr val="accent1"/>
+          </a:lnRef>
+          <a:fillRef idx="3">
+            <a:schemeClr val="accent1"/>
+          </a:fillRef>
+          <a:effectRef idx="2">
+            <a:schemeClr val="accent1"/>
+          </a:effectRef>
+          <a:fontRef idx="minor">
+            <a:schemeClr val="lt1"/>
+          </a:fontRef>
+        </p:style>
+        <p:txBody>
+          <a:bodyPr rtlCol="0" anchor="ctr"/>
+          <a:lstStyle/>
+          <a:p>
+            <a:pPr algn="ctr"/>
+          </a:p>
+        </p:txBody>
+      </p:sp>
+      <p:sp>
+        <p:nvSpPr>
+          <p:cNvPr id="3" name="TextBox 2"/>
+          <p:cNvSpPr txBox="1"/>
+          <p:nvPr/>
+        </p:nvSpPr>
+        <p:spPr>
+          <a:xfrm>
+            <a:off x="251999" y="0"/>
+            <a:ext cx="10972800" cy="310896"/>
+          </a:xfrm>
+          <a:prstGeom prst="rect">
+            <a:avLst/>
+          </a:prstGeom>
+          <a:noFill/>
+        </p:spPr>
+        <p:txBody>
+          <a:bodyPr wrap="square" lIns="0" rIns="0" tIns="0" bIns="0" anchor="ctr">
+            <a:spAutoFit/>
+          </a:bodyPr>
+          <a:lstStyle/>
+          <a:p>
+            <a:pPr algn="l"/>
+            <a:r>
+              <a:rPr sz="1100" b="1" i="0">
+                <a:solidFill>
+                  <a:srgbClr val="FFFFFF"/>
+                </a:solidFill>
+                <a:latin typeface="Calibri"/>
+              </a:rPr>
+              <a:t>MODULE 3 · PART 1 · PRODUCTION</a:t>
+            </a:r>
+          </a:p>
+        </p:txBody>
+      </p:sp>
+      <p:sp>
+        <p:nvSpPr>
+          <p:cNvPr id="4" name="TextBox 3"/>
+          <p:cNvSpPr txBox="1"/>
+          <p:nvPr/>
+        </p:nvSpPr>
+        <p:spPr>
+          <a:xfrm>
+            <a:off x="251999" y="502920"/>
+            <a:ext cx="11687697" cy="640080"/>
+          </a:xfrm>
+          <a:prstGeom prst="rect">
+            <a:avLst/>
+          </a:prstGeom>
+          <a:noFill/>
+        </p:spPr>
+        <p:txBody>
+          <a:bodyPr wrap="square" lIns="0" rIns="0" tIns="0" bIns="0">
+            <a:spAutoFit/>
+          </a:bodyPr>
+          <a:lstStyle/>
+          <a:p>
+            <a:pPr algn="l"/>
+            <a:r>
+              <a:rPr sz="3200" b="1" i="0">
+                <a:solidFill>
+                  <a:srgbClr val="0B2B4E"/>
+                </a:solidFill>
+                <a:latin typeface="Calibri"/>
+              </a:rPr>
+              <a:t>Tesla's MRPL at 6,000 employees – what is it?</a:t>
+            </a:r>
+          </a:p>
+        </p:txBody>
+      </p:sp>
+      <p:sp>
+        <p:nvSpPr>
+          <p:cNvPr id="5" name="Rectangle 4"/>
+          <p:cNvSpPr/>
+          <p:nvPr/>
+        </p:nvSpPr>
+        <p:spPr>
+          <a:xfrm>
+            <a:off x="251999" y="1143000"/>
+            <a:ext cx="11687697" cy="18288"/>
+          </a:xfrm>
+          <a:prstGeom prst="rect">
+            <a:avLst/>
+          </a:prstGeom>
+          <a:solidFill>
+            <a:srgbClr val="C8CDD3"/>
+          </a:solidFill>
+          <a:ln>
+            <a:noFill/>
+          </a:ln>
+          <a:effectLst/>
+        </p:spPr>
+        <p:style>
+          <a:lnRef idx="1">
+            <a:schemeClr val="accent1"/>
+          </a:lnRef>
+          <a:fillRef idx="3">
+            <a:schemeClr val="accent1"/>
+          </a:fillRef>
+          <a:effectRef idx="2">
+            <a:schemeClr val="accent1"/>
+          </a:effectRef>
+          <a:fontRef idx="minor">
+            <a:schemeClr val="lt1"/>
+          </a:fontRef>
+        </p:style>
+        <p:txBody>
+          <a:bodyPr rtlCol="0" anchor="ctr"/>
+          <a:lstStyle/>
+          <a:p>
+            <a:pPr algn="ctr"/>
+          </a:p>
+        </p:txBody>
+      </p:sp>
+      <p:sp>
+        <p:nvSpPr>
+          <p:cNvPr id="6" name="Rectangle 5"/>
+          <p:cNvSpPr/>
+          <p:nvPr/>
+        </p:nvSpPr>
+        <p:spPr>
+          <a:xfrm>
+            <a:off x="251999" y="1129284"/>
+            <a:ext cx="2011680" cy="45720"/>
+          </a:xfrm>
+          <a:prstGeom prst="rect">
+            <a:avLst/>
+          </a:prstGeom>
+          <a:solidFill>
+            <a:srgbClr val="E09F3E"/>
+          </a:solidFill>
+          <a:ln>
+            <a:noFill/>
+          </a:ln>
+          <a:effectLst/>
+        </p:spPr>
+        <p:style>
+          <a:lnRef idx="1">
+            <a:schemeClr val="accent1"/>
+          </a:lnRef>
+          <a:fillRef idx="3">
+            <a:schemeClr val="accent1"/>
+          </a:fillRef>
+          <a:effectRef idx="2">
+            <a:schemeClr val="accent1"/>
+          </a:effectRef>
+          <a:fontRef idx="minor">
+            <a:schemeClr val="lt1"/>
+          </a:fontRef>
+        </p:style>
+        <p:txBody>
+          <a:bodyPr rtlCol="0" anchor="ctr"/>
+          <a:lstStyle/>
+          <a:p>
+            <a:pPr algn="ctr"/>
+          </a:p>
+        </p:txBody>
+      </p:sp>
+      <p:sp>
+        <p:nvSpPr>
+          <p:cNvPr id="7" name="Rounded Rectangle 6"/>
+          <p:cNvSpPr/>
+          <p:nvPr/>
+        </p:nvSpPr>
+        <p:spPr>
+          <a:xfrm>
+            <a:off x="10979576" y="502920"/>
+            <a:ext cx="960120" cy="310896"/>
+          </a:xfrm>
+          <a:prstGeom prst="roundRect">
+            <a:avLst>
+              <a:gd name="adj" fmla="val 50000"/>
+            </a:avLst>
+          </a:prstGeom>
+          <a:solidFill>
+            <a:srgbClr val="0B2B4E"/>
+          </a:solidFill>
+          <a:ln>
+            <a:noFill/>
+          </a:ln>
+          <a:effectLst/>
+        </p:spPr>
+        <p:style>
+          <a:lnRef idx="1">
+            <a:schemeClr val="accent1"/>
+          </a:lnRef>
+          <a:fillRef idx="3">
+            <a:schemeClr val="accent1"/>
+          </a:fillRef>
+          <a:effectRef idx="2">
+            <a:schemeClr val="accent1"/>
+          </a:effectRef>
+          <a:fontRef idx="minor">
+            <a:schemeClr val="lt1"/>
+          </a:fontRef>
+        </p:style>
+        <p:txBody>
+          <a:bodyPr rtlCol="0" anchor="ctr"/>
+          <a:lstStyle/>
+          <a:p>
+            <a:pPr algn="ctr"/>
+          </a:p>
+        </p:txBody>
+      </p:sp>
+      <p:sp>
+        <p:nvSpPr>
+          <p:cNvPr id="8" name="TextBox 7"/>
+          <p:cNvSpPr txBox="1"/>
+          <p:nvPr/>
+        </p:nvSpPr>
+        <p:spPr>
+          <a:xfrm>
+            <a:off x="10979576" y="502920"/>
+            <a:ext cx="960120" cy="310896"/>
+          </a:xfrm>
+          <a:prstGeom prst="rect">
+            <a:avLst/>
+          </a:prstGeom>
+          <a:noFill/>
+        </p:spPr>
+        <p:txBody>
+          <a:bodyPr wrap="square" lIns="0" rIns="0" tIns="0" bIns="0" anchor="ctr">
+            <a:spAutoFit/>
+          </a:bodyPr>
+          <a:lstStyle/>
+          <a:p>
+            <a:pPr algn="ctr"/>
+            <a:r>
+              <a:rPr sz="1200" b="1" i="0">
+                <a:solidFill>
+                  <a:srgbClr val="FFFFFF"/>
+                </a:solidFill>
+                <a:latin typeface="Calibri"/>
+              </a:rPr>
+              <a:t>POLL</a:t>
+            </a:r>
+          </a:p>
+        </p:txBody>
+      </p:sp>
+      <p:sp>
+        <p:nvSpPr>
+          <p:cNvPr id="9" name="Rectangle 8"/>
+          <p:cNvSpPr/>
+          <p:nvPr/>
+        </p:nvSpPr>
+        <p:spPr>
+          <a:xfrm>
+            <a:off x="10705256" y="594360"/>
+            <a:ext cx="128016" cy="128016"/>
+          </a:xfrm>
+          <a:prstGeom prst="rect">
+            <a:avLst/>
+          </a:prstGeom>
+          <a:solidFill>
+            <a:srgbClr val="E09F3E"/>
+          </a:solidFill>
+          <a:ln>
+            <a:noFill/>
+          </a:ln>
+          <a:effectLst/>
+        </p:spPr>
+        <p:style>
+          <a:lnRef idx="1">
+            <a:schemeClr val="accent1"/>
+          </a:lnRef>
+          <a:fillRef idx="3">
+            <a:schemeClr val="accent1"/>
+          </a:fillRef>
+          <a:effectRef idx="2">
+            <a:schemeClr val="accent1"/>
+          </a:effectRef>
+          <a:fontRef idx="minor">
+            <a:schemeClr val="lt1"/>
+          </a:fontRef>
+        </p:style>
+        <p:txBody>
+          <a:bodyPr rtlCol="0" anchor="ctr"/>
+          <a:lstStyle/>
+          <a:p>
+            <a:pPr algn="ctr"/>
+          </a:p>
+        </p:txBody>
+      </p:sp>
+      <p:sp>
+        <p:nvSpPr>
+          <p:cNvPr id="10" name="TextBox 9"/>
+          <p:cNvSpPr txBox="1"/>
+          <p:nvPr/>
+        </p:nvSpPr>
+        <p:spPr>
+          <a:xfrm>
+            <a:off x="251999" y="1828800"/>
+            <a:ext cx="11687697" cy="3657600"/>
+          </a:xfrm>
+          <a:prstGeom prst="rect">
+            <a:avLst/>
+          </a:prstGeom>
+          <a:noFill/>
+        </p:spPr>
+        <p:txBody>
+          <a:bodyPr wrap="square" lIns="0" rIns="0" tIns="0" bIns="0">
+            <a:spAutoFit/>
+          </a:bodyPr>
+          <a:lstStyle/>
+          <a:p>
+            <a:pPr algn="l" marL="457200" indent="-457200">
+              <a:buClr>
+                <a:srgbClr val="0B2B4E"/>
+              </a:buClr>
+              <a:buFont typeface="Calibri"/>
+              <a:buAutoNum type="alphaUcPeriod"/>
+            </a:pPr>
+            <a:r>
+              <a:rPr sz="2600" b="0">
+                <a:solidFill>
+                  <a:srgbClr val="0B2B4E"/>
+                </a:solidFill>
+                <a:latin typeface="Calibri"/>
+              </a:rPr>
+              <a:t>$25,000</a:t>
+            </a:r>
+          </a:p>
+          <a:p>
+            <a:pPr algn="l" marL="457200" indent="-457200">
+              <a:spcBef>
+                <a:spcPts val="2000"/>
+              </a:spcBef>
+              <a:buClr>
+                <a:srgbClr val="0B2B4E"/>
+              </a:buClr>
+              <a:buFont typeface="Calibri"/>
+              <a:buAutoNum type="alphaUcPeriod"/>
+            </a:pPr>
+            <a:r>
+              <a:rPr sz="2600" b="0">
+                <a:solidFill>
+                  <a:srgbClr val="0B2B4E"/>
+                </a:solidFill>
+                <a:latin typeface="Calibri"/>
+              </a:rPr>
+              <a:t>$50,000</a:t>
+            </a:r>
+          </a:p>
+          <a:p>
+            <a:pPr algn="l" marL="457200" indent="-457200">
+              <a:spcBef>
+                <a:spcPts val="2000"/>
+              </a:spcBef>
+              <a:buClr>
+                <a:srgbClr val="0B2B4E"/>
+              </a:buClr>
+              <a:buFont typeface="Calibri"/>
+              <a:buAutoNum type="alphaUcPeriod"/>
+            </a:pPr>
+            <a:r>
+              <a:rPr sz="2600" b="0">
+                <a:solidFill>
+                  <a:srgbClr val="0B2B4E"/>
+                </a:solidFill>
+                <a:latin typeface="Calibri"/>
+              </a:rPr>
+              <a:t>$75,000</a:t>
+            </a:r>
+          </a:p>
+          <a:p>
+            <a:pPr algn="l" marL="457200" indent="-457200">
+              <a:spcBef>
+                <a:spcPts val="2000"/>
+              </a:spcBef>
+              <a:buClr>
+                <a:srgbClr val="0B2B4E"/>
+              </a:buClr>
+              <a:buFont typeface="Calibri"/>
+              <a:buAutoNum type="alphaUcPeriod"/>
+            </a:pPr>
+            <a:r>
+              <a:rPr sz="2600" b="0">
+                <a:solidFill>
+                  <a:srgbClr val="0B2B4E"/>
+                </a:solidFill>
+                <a:latin typeface="Calibri"/>
+              </a:rPr>
+              <a:t>$100,000</a:t>
+            </a:r>
+          </a:p>
+        </p:txBody>
+      </p:sp>
+      <p:sp>
+        <p:nvSpPr>
+          <p:cNvPr id="11" name="TextBox 10"/>
+          <p:cNvSpPr txBox="1"/>
+          <p:nvPr/>
+        </p:nvSpPr>
+        <p:spPr>
+          <a:xfrm>
+            <a:off x="251999" y="5943600"/>
+            <a:ext cx="11687697" cy="365760"/>
+          </a:xfrm>
+          <a:prstGeom prst="rect">
+            <a:avLst/>
+          </a:prstGeom>
+          <a:noFill/>
+        </p:spPr>
+        <p:txBody>
+          <a:bodyPr wrap="square" lIns="0" rIns="0" tIns="0" bIns="0">
+            <a:spAutoFit/>
+          </a:bodyPr>
+          <a:lstStyle/>
+          <a:p>
+            <a:pPr algn="r"/>
+            <a:r>
+              <a:rPr sz="1400" b="0" i="1">
+                <a:solidFill>
+                  <a:srgbClr val="555B66"/>
+                </a:solidFill>
+                <a:latin typeface="Calibri"/>
+              </a:rPr>
+              <a:t>Respond at PollEv.com/nvoigtlaender</a:t>
+            </a:r>
+          </a:p>
+        </p:txBody>
+      </p:sp>
+      <p:sp>
+        <p:nvSpPr>
+          <p:cNvPr id="12" name="Rectangle 11"/>
+          <p:cNvSpPr/>
+          <p:nvPr/>
+        </p:nvSpPr>
+        <p:spPr>
+          <a:xfrm>
+            <a:off x="0" y="6537960"/>
+            <a:ext cx="12191695" cy="18288"/>
+          </a:xfrm>
+          <a:prstGeom prst="rect">
+            <a:avLst/>
+          </a:prstGeom>
+          <a:solidFill>
+            <a:srgbClr val="C8CDD3"/>
+          </a:solidFill>
+          <a:ln>
+            <a:noFill/>
+          </a:ln>
+          <a:effectLst/>
+        </p:spPr>
+        <p:style>
+          <a:lnRef idx="1">
+            <a:schemeClr val="accent1"/>
+          </a:lnRef>
+          <a:fillRef idx="3">
+            <a:schemeClr val="accent1"/>
+          </a:fillRef>
+          <a:effectRef idx="2">
+            <a:schemeClr val="accent1"/>
+          </a:effectRef>
+          <a:fontRef idx="minor">
+            <a:schemeClr val="lt1"/>
+          </a:fontRef>
+        </p:style>
+        <p:txBody>
+          <a:bodyPr rtlCol="0" anchor="ctr"/>
+          <a:lstStyle/>
+          <a:p>
+            <a:pPr algn="ctr"/>
+          </a:p>
+        </p:txBody>
+      </p:sp>
+      <p:sp>
+        <p:nvSpPr>
+          <p:cNvPr id="13" name="Rectangle 12"/>
+          <p:cNvSpPr/>
+          <p:nvPr/>
+        </p:nvSpPr>
+        <p:spPr>
+          <a:xfrm>
+            <a:off x="251999" y="6524244"/>
+            <a:ext cx="2011680" cy="45720"/>
+          </a:xfrm>
+          <a:prstGeom prst="rect">
+            <a:avLst/>
+          </a:prstGeom>
+          <a:solidFill>
+            <a:srgbClr val="E09F3E"/>
+          </a:solidFill>
+          <a:ln>
+            <a:noFill/>
+          </a:ln>
+          <a:effectLst/>
+        </p:spPr>
+        <p:style>
+          <a:lnRef idx="1">
+            <a:schemeClr val="accent1"/>
+          </a:lnRef>
+          <a:fillRef idx="3">
+            <a:schemeClr val="accent1"/>
+          </a:fillRef>
+          <a:effectRef idx="2">
+            <a:schemeClr val="accent1"/>
+          </a:effectRef>
+          <a:fontRef idx="minor">
+            <a:schemeClr val="lt1"/>
+          </a:fontRef>
+        </p:style>
+        <p:txBody>
+          <a:bodyPr rtlCol="0" anchor="ctr"/>
+          <a:lstStyle/>
+          <a:p>
+            <a:pPr algn="ctr"/>
+          </a:p>
+        </p:txBody>
+      </p:sp>
+      <p:sp>
+        <p:nvSpPr>
+          <p:cNvPr id="14" name="TextBox 13"/>
+          <p:cNvSpPr txBox="1"/>
+          <p:nvPr/>
+        </p:nvSpPr>
+        <p:spPr>
+          <a:xfrm>
+            <a:off x="251999" y="6601968"/>
+            <a:ext cx="10058400" cy="274320"/>
+          </a:xfrm>
+          <a:prstGeom prst="rect">
+            <a:avLst/>
+          </a:prstGeom>
+          <a:noFill/>
+        </p:spPr>
+        <p:txBody>
+          <a:bodyPr wrap="square" lIns="0" rIns="0" tIns="0" bIns="0">
+            <a:spAutoFit/>
+          </a:bodyPr>
+          <a:lstStyle/>
+          <a:p>
+            <a:pPr algn="l"/>
+            <a:r>
+              <a:rPr sz="1000" b="0" i="0">
+                <a:solidFill>
+                  <a:srgbClr val="555B66"/>
+                </a:solidFill>
+                <a:latin typeface="Calibri"/>
+              </a:rPr>
+              <a:t>Management 405  ·  Module 3  ·  Production and Costs</a:t>
+            </a:r>
+          </a:p>
+        </p:txBody>
+      </p:sp>
+      <p:sp>
+        <p:nvSpPr>
+          <p:cNvPr id="15" name="TextBox 14"/>
+          <p:cNvSpPr txBox="1"/>
+          <p:nvPr/>
+        </p:nvSpPr>
+        <p:spPr>
+          <a:xfrm>
+            <a:off x="11521440" y="6601968"/>
+            <a:ext cx="457200" cy="274320"/>
+          </a:xfrm>
+          <a:prstGeom prst="rect">
+            <a:avLst/>
+          </a:prstGeom>
+          <a:noFill/>
+        </p:spPr>
+        <p:txBody>
+          <a:bodyPr wrap="square" lIns="0" rIns="0" tIns="0" bIns="0">
+            <a:spAutoFit/>
+          </a:bodyPr>
+          <a:lstStyle/>
+          <a:p>
+            <a:pPr algn="r"/>
+            <a:r>
+              <a:rPr sz="1000" b="0" i="0">
+                <a:solidFill>
+                  <a:srgbClr val="555B66"/>
+                </a:solidFill>
+                <a:latin typeface="Calibri"/>
+              </a:rPr>
+              <a:t>24</a:t>
+            </a:r>
+          </a:p>
+        </p:txBody>
+      </p:sp>
+    </p:spTree>
+  </p:cSld>
+  <p:clrMapOvr>
+    <a:masterClrMapping/>
+  </p:clrMapOvr>
+</p:sld>
+</file>
+
+<file path=ppt/slides/slide6.xml><?xml version="1.0" encoding="utf-8"?>
+<p:sld xmlns:a="http://schemas.openxmlformats.org/drawingml/2006/main" xmlns:p="http://schemas.openxmlformats.org/presentationml/2006/main" xmlns:r="http://schemas.openxmlformats.org/officeDocument/2006/relationships">
+  <p:cSld>
+    <p:spTree>
+      <p:nvGrpSpPr>
+        <p:cNvPr id="1" name=""/>
+        <p:cNvGrpSpPr/>
+        <p:nvPr/>
+      </p:nvGrpSpPr>
+      <p:grpSpPr/>
+      <p:sp>
+        <p:nvSpPr>
+          <p:cNvPr id="2" name="Rectangle 1"/>
+          <p:cNvSpPr/>
+          <p:nvPr/>
+        </p:nvSpPr>
+        <p:spPr>
+          <a:xfrm>
+            <a:off x="0" y="0"/>
+            <a:ext cx="12191695" cy="310896"/>
+          </a:xfrm>
+          <a:prstGeom prst="rect">
+            <a:avLst/>
+          </a:prstGeom>
+          <a:solidFill>
+            <a:srgbClr val="0B2B4E"/>
+          </a:solidFill>
+          <a:ln>
+            <a:noFill/>
+          </a:ln>
+          <a:effectLst/>
+        </p:spPr>
+        <p:style>
+          <a:lnRef idx="1">
+            <a:schemeClr val="accent1"/>
+          </a:lnRef>
+          <a:fillRef idx="3">
+            <a:schemeClr val="accent1"/>
+          </a:fillRef>
+          <a:effectRef idx="2">
+            <a:schemeClr val="accent1"/>
+          </a:effectRef>
+          <a:fontRef idx="minor">
+            <a:schemeClr val="lt1"/>
+          </a:fontRef>
+        </p:style>
+        <p:txBody>
+          <a:bodyPr rtlCol="0" anchor="ctr"/>
+          <a:lstStyle/>
+          <a:p>
+            <a:pPr algn="ctr"/>
+          </a:p>
+        </p:txBody>
+      </p:sp>
+      <p:sp>
+        <p:nvSpPr>
+          <p:cNvPr id="3" name="TextBox 2"/>
+          <p:cNvSpPr txBox="1"/>
+          <p:nvPr/>
+        </p:nvSpPr>
+        <p:spPr>
+          <a:xfrm>
+            <a:off x="251999" y="0"/>
+            <a:ext cx="10972800" cy="310896"/>
+          </a:xfrm>
+          <a:prstGeom prst="rect">
+            <a:avLst/>
+          </a:prstGeom>
+          <a:noFill/>
+        </p:spPr>
+        <p:txBody>
+          <a:bodyPr wrap="square" lIns="0" rIns="0" tIns="0" bIns="0" anchor="ctr">
+            <a:spAutoFit/>
+          </a:bodyPr>
+          <a:lstStyle/>
+          <a:p>
+            <a:pPr algn="l"/>
+            <a:r>
+              <a:rPr sz="1100" b="1" i="0">
+                <a:solidFill>
+                  <a:srgbClr val="FFFFFF"/>
+                </a:solidFill>
+                <a:latin typeface="Calibri"/>
+              </a:rPr>
+              <a:t>MODULE 3 · SYNTHESIS &amp; BRIDGE TO MODULE 4</a:t>
+            </a:r>
+          </a:p>
+        </p:txBody>
+      </p:sp>
+      <p:sp>
+        <p:nvSpPr>
+          <p:cNvPr id="4" name="TextBox 3"/>
+          <p:cNvSpPr txBox="1"/>
+          <p:nvPr/>
+        </p:nvSpPr>
+        <p:spPr>
+          <a:xfrm>
+            <a:off x="251999" y="502920"/>
+            <a:ext cx="11687697" cy="640080"/>
+          </a:xfrm>
+          <a:prstGeom prst="rect">
+            <a:avLst/>
+          </a:prstGeom>
+          <a:noFill/>
+        </p:spPr>
+        <p:txBody>
+          <a:bodyPr wrap="square" lIns="0" rIns="0" tIns="0" bIns="0">
+            <a:spAutoFit/>
+          </a:bodyPr>
+          <a:lstStyle/>
+          <a:p>
+            <a:pPr algn="l"/>
+            <a:r>
+              <a:rPr sz="3200" b="1" i="0">
+                <a:solidFill>
+                  <a:srgbClr val="0B2B4E"/>
+                </a:solidFill>
+                <a:latin typeface="Calibri"/>
+              </a:rPr>
+              <a:t>Production and costs set the stage for pricing and profit</a:t>
+            </a:r>
+          </a:p>
+        </p:txBody>
+      </p:sp>
+      <p:sp>
+        <p:nvSpPr>
+          <p:cNvPr id="5" name="Rectangle 4"/>
+          <p:cNvSpPr/>
+          <p:nvPr/>
+        </p:nvSpPr>
+        <p:spPr>
+          <a:xfrm>
+            <a:off x="251999" y="1143000"/>
+            <a:ext cx="11687697" cy="18288"/>
+          </a:xfrm>
+          <a:prstGeom prst="rect">
+            <a:avLst/>
+          </a:prstGeom>
+          <a:solidFill>
+            <a:srgbClr val="C8CDD3"/>
+          </a:solidFill>
+          <a:ln>
+            <a:noFill/>
+          </a:ln>
+          <a:effectLst/>
+        </p:spPr>
+        <p:style>
+          <a:lnRef idx="1">
+            <a:schemeClr val="accent1"/>
+          </a:lnRef>
+          <a:fillRef idx="3">
+            <a:schemeClr val="accent1"/>
+          </a:fillRef>
+          <a:effectRef idx="2">
+            <a:schemeClr val="accent1"/>
+          </a:effectRef>
+          <a:fontRef idx="minor">
+            <a:schemeClr val="lt1"/>
+          </a:fontRef>
+        </p:style>
+        <p:txBody>
+          <a:bodyPr rtlCol="0" anchor="ctr"/>
+          <a:lstStyle/>
+          <a:p>
+            <a:pPr algn="ctr"/>
+          </a:p>
+        </p:txBody>
+      </p:sp>
+      <p:sp>
+        <p:nvSpPr>
+          <p:cNvPr id="6" name="Rectangle 5"/>
+          <p:cNvSpPr/>
+          <p:nvPr/>
+        </p:nvSpPr>
+        <p:spPr>
+          <a:xfrm>
+            <a:off x="251999" y="1129284"/>
+            <a:ext cx="2011680" cy="45720"/>
+          </a:xfrm>
+          <a:prstGeom prst="rect">
+            <a:avLst/>
+          </a:prstGeom>
+          <a:solidFill>
+            <a:srgbClr val="E09F3E"/>
+          </a:solidFill>
+          <a:ln>
+            <a:noFill/>
+          </a:ln>
+          <a:effectLst/>
+        </p:spPr>
+        <p:style>
+          <a:lnRef idx="1">
+            <a:schemeClr val="accent1"/>
+          </a:lnRef>
+          <a:fillRef idx="3">
+            <a:schemeClr val="accent1"/>
+          </a:fillRef>
+          <a:effectRef idx="2">
+            <a:schemeClr val="accent1"/>
+          </a:effectRef>
+          <a:fontRef idx="minor">
+            <a:schemeClr val="lt1"/>
+          </a:fontRef>
+        </p:style>
+        <p:txBody>
+          <a:bodyPr rtlCol="0" anchor="ctr"/>
+          <a:lstStyle/>
+          <a:p>
+            <a:pPr algn="ctr"/>
+          </a:p>
+        </p:txBody>
+      </p:sp>
+      <p:sp>
+        <p:nvSpPr>
+          <p:cNvPr id="7" name="TextBox 6"/>
+          <p:cNvSpPr txBox="1"/>
+          <p:nvPr/>
+        </p:nvSpPr>
+        <p:spPr>
+          <a:xfrm>
+            <a:off x="251999" y="1691640"/>
+            <a:ext cx="11687697" cy="411480"/>
+          </a:xfrm>
+          <a:prstGeom prst="rect">
+            <a:avLst/>
+          </a:prstGeom>
+          <a:noFill/>
+        </p:spPr>
+        <p:txBody>
+          <a:bodyPr wrap="square" lIns="0" rIns="0" tIns="0" bIns="0">
+            <a:spAutoFit/>
+          </a:bodyPr>
+          <a:lstStyle/>
+          <a:p>
+            <a:pPr algn="l"/>
+            <a:r>
+              <a:rPr sz="1400" b="1" i="0">
+                <a:solidFill>
+                  <a:srgbClr val="0B2B4E"/>
+                </a:solidFill>
+                <a:latin typeface="Calibri"/>
+              </a:rPr>
+              <a:t>MODULE 3 RECAP</a:t>
+            </a:r>
+          </a:p>
+        </p:txBody>
+      </p:sp>
+      <p:sp>
+        <p:nvSpPr>
+          <p:cNvPr id="8" name="TextBox 7"/>
+          <p:cNvSpPr txBox="1"/>
+          <p:nvPr/>
+        </p:nvSpPr>
+        <p:spPr>
+          <a:xfrm>
+            <a:off x="251999" y="2148840"/>
+            <a:ext cx="2011680" cy="502920"/>
+          </a:xfrm>
+          <a:prstGeom prst="rect">
+            <a:avLst/>
+          </a:prstGeom>
+          <a:noFill/>
+        </p:spPr>
+        <p:txBody>
+          <a:bodyPr wrap="square" lIns="0" rIns="0" tIns="0" bIns="0">
+            <a:spAutoFit/>
+          </a:bodyPr>
+          <a:lstStyle/>
+          <a:p>
+            <a:pPr algn="l"/>
+            <a:r>
+              <a:rPr sz="1800" b="1" i="0">
+                <a:solidFill>
+                  <a:srgbClr val="0B2B4E"/>
+                </a:solidFill>
+                <a:latin typeface="Calibri"/>
+              </a:rPr>
+              <a:t>Production</a:t>
+            </a:r>
+          </a:p>
+        </p:txBody>
+      </p:sp>
+      <p:sp>
+        <p:nvSpPr>
+          <p:cNvPr id="9" name="TextBox 8"/>
+          <p:cNvSpPr txBox="1"/>
+          <p:nvPr/>
+        </p:nvSpPr>
+        <p:spPr>
+          <a:xfrm>
+            <a:off x="2446559" y="2148840"/>
+            <a:ext cx="9493137" cy="502920"/>
+          </a:xfrm>
+          <a:prstGeom prst="rect">
+            <a:avLst/>
+          </a:prstGeom>
+          <a:noFill/>
+        </p:spPr>
+        <p:txBody>
+          <a:bodyPr wrap="square" lIns="0" rIns="0" tIns="0" bIns="0">
+            <a:spAutoFit/>
+          </a:bodyPr>
+          <a:lstStyle/>
+          <a:p>
+            <a:pPr algn="l"/>
+            <a:r>
+              <a:rPr sz="1800" b="0" i="0">
+                <a:solidFill>
+                  <a:srgbClr val="555B66"/>
+                </a:solidFill>
+                <a:latin typeface="Calibri"/>
+              </a:rPr>
+              <a:t>Hire until MRPL = wage; choose inputs by bang-for-the-buck</a:t>
+            </a:r>
+          </a:p>
+        </p:txBody>
+      </p:sp>
+      <p:sp>
+        <p:nvSpPr>
+          <p:cNvPr id="10" name="TextBox 9"/>
+          <p:cNvSpPr txBox="1"/>
+          <p:nvPr/>
+        </p:nvSpPr>
+        <p:spPr>
+          <a:xfrm>
+            <a:off x="251999" y="2651760"/>
+            <a:ext cx="2011680" cy="502920"/>
+          </a:xfrm>
+          <a:prstGeom prst="rect">
+            <a:avLst/>
+          </a:prstGeom>
+          <a:noFill/>
+        </p:spPr>
+        <p:txBody>
+          <a:bodyPr wrap="square" lIns="0" rIns="0" tIns="0" bIns="0">
+            <a:spAutoFit/>
+          </a:bodyPr>
+          <a:lstStyle/>
+          <a:p>
+            <a:pPr algn="l"/>
+            <a:r>
+              <a:rPr sz="1800" b="1" i="0">
+                <a:solidFill>
+                  <a:srgbClr val="0B2B4E"/>
+                </a:solidFill>
+                <a:latin typeface="Calibri"/>
+              </a:rPr>
+              <a:t>Costs</a:t>
+            </a:r>
+          </a:p>
+        </p:txBody>
+      </p:sp>
+      <p:sp>
+        <p:nvSpPr>
+          <p:cNvPr id="11" name="TextBox 10"/>
+          <p:cNvSpPr txBox="1"/>
+          <p:nvPr/>
+        </p:nvSpPr>
+        <p:spPr>
+          <a:xfrm>
+            <a:off x="2446559" y="2651760"/>
+            <a:ext cx="9493137" cy="502920"/>
+          </a:xfrm>
+          <a:prstGeom prst="rect">
+            <a:avLst/>
+          </a:prstGeom>
+          <a:noFill/>
+        </p:spPr>
+        <p:txBody>
+          <a:bodyPr wrap="square" lIns="0" rIns="0" tIns="0" bIns="0">
+            <a:spAutoFit/>
+          </a:bodyPr>
+          <a:lstStyle/>
+          <a:p>
+            <a:pPr algn="l"/>
+            <a:r>
+              <a:rPr sz="1800" b="0" i="0">
+                <a:solidFill>
+                  <a:srgbClr val="555B66"/>
+                </a:solidFill>
+                <a:latin typeface="Calibri"/>
+              </a:rPr>
+              <a:t>Ignore sunk; opportunity cost is real; watch MC vs. AC</a:t>
+            </a:r>
+          </a:p>
+        </p:txBody>
+      </p:sp>
+      <p:sp>
+        <p:nvSpPr>
+          <p:cNvPr id="12" name="TextBox 11"/>
+          <p:cNvSpPr txBox="1"/>
+          <p:nvPr/>
+        </p:nvSpPr>
+        <p:spPr>
+          <a:xfrm>
+            <a:off x="251999" y="3154680"/>
+            <a:ext cx="2011680" cy="502920"/>
+          </a:xfrm>
+          <a:prstGeom prst="rect">
+            <a:avLst/>
+          </a:prstGeom>
+          <a:noFill/>
+        </p:spPr>
+        <p:txBody>
+          <a:bodyPr wrap="square" lIns="0" rIns="0" tIns="0" bIns="0">
+            <a:spAutoFit/>
+          </a:bodyPr>
+          <a:lstStyle/>
+          <a:p>
+            <a:pPr algn="l"/>
+            <a:r>
+              <a:rPr sz="1800" b="1" i="0">
+                <a:solidFill>
+                  <a:srgbClr val="0B2B4E"/>
+                </a:solidFill>
+                <a:latin typeface="Calibri"/>
+              </a:rPr>
+              <a:t>Scale</a:t>
+            </a:r>
+          </a:p>
+        </p:txBody>
+      </p:sp>
+      <p:sp>
+        <p:nvSpPr>
+          <p:cNvPr id="13" name="TextBox 12"/>
+          <p:cNvSpPr txBox="1"/>
+          <p:nvPr/>
+        </p:nvSpPr>
+        <p:spPr>
+          <a:xfrm>
+            <a:off x="2446559" y="3154680"/>
+            <a:ext cx="9493137" cy="502920"/>
+          </a:xfrm>
+          <a:prstGeom prst="rect">
+            <a:avLst/>
+          </a:prstGeom>
+          <a:noFill/>
+        </p:spPr>
+        <p:txBody>
+          <a:bodyPr wrap="square" lIns="0" rIns="0" tIns="0" bIns="0">
+            <a:spAutoFit/>
+          </a:bodyPr>
+          <a:lstStyle/>
+          <a:p>
+            <a:pPr algn="l"/>
+            <a:r>
+              <a:rPr sz="1800" b="0" i="0">
+                <a:solidFill>
+                  <a:srgbClr val="555B66"/>
+                </a:solidFill>
+                <a:latin typeface="Calibri"/>
+              </a:rPr>
+              <a:t>Bigger is often cheaper – until diseconomies set in</a:t>
+            </a:r>
+          </a:p>
+        </p:txBody>
+      </p:sp>
+      <p:sp>
+        <p:nvSpPr>
+          <p:cNvPr id="14" name="Rectangle 13"/>
+          <p:cNvSpPr/>
+          <p:nvPr/>
+        </p:nvSpPr>
+        <p:spPr>
+          <a:xfrm>
+            <a:off x="251999" y="3931920"/>
+            <a:ext cx="11687697" cy="36576"/>
+          </a:xfrm>
+          <a:prstGeom prst="rect">
+            <a:avLst/>
+          </a:prstGeom>
+          <a:solidFill>
+            <a:srgbClr val="E09F3E"/>
+          </a:solidFill>
+          <a:ln>
+            <a:noFill/>
+          </a:ln>
+          <a:effectLst/>
+        </p:spPr>
+        <p:style>
+          <a:lnRef idx="1">
+            <a:schemeClr val="accent1"/>
+          </a:lnRef>
+          <a:fillRef idx="3">
+            <a:schemeClr val="accent1"/>
+          </a:fillRef>
+          <a:effectRef idx="2">
+            <a:schemeClr val="accent1"/>
+          </a:effectRef>
+          <a:fontRef idx="minor">
+            <a:schemeClr val="lt1"/>
+          </a:fontRef>
+        </p:style>
+        <p:txBody>
+          <a:bodyPr rtlCol="0" anchor="ctr"/>
+          <a:lstStyle/>
+          <a:p>
+            <a:pPr algn="ctr"/>
+          </a:p>
+        </p:txBody>
+      </p:sp>
+      <p:sp>
+        <p:nvSpPr>
+          <p:cNvPr id="15" name="TextBox 14"/>
+          <p:cNvSpPr txBox="1"/>
+          <p:nvPr/>
+        </p:nvSpPr>
+        <p:spPr>
+          <a:xfrm>
+            <a:off x="251999" y="4160520"/>
+            <a:ext cx="11687697" cy="411480"/>
+          </a:xfrm>
+          <a:prstGeom prst="rect">
+            <a:avLst/>
+          </a:prstGeom>
+          <a:noFill/>
+        </p:spPr>
+        <p:txBody>
+          <a:bodyPr wrap="square" lIns="0" rIns="0" tIns="0" bIns="0">
+            <a:spAutoFit/>
+          </a:bodyPr>
+          <a:lstStyle/>
+          <a:p>
+            <a:pPr algn="l"/>
+            <a:r>
+              <a:rPr sz="1400" b="1" i="0">
+                <a:solidFill>
+                  <a:srgbClr val="E09F3E"/>
+                </a:solidFill>
+                <a:latin typeface="Calibri"/>
+              </a:rPr>
+              <a:t>COMING UP – MODULE 4: PRICING &amp; PROFIT</a:t>
+            </a:r>
+          </a:p>
+        </p:txBody>
+      </p:sp>
+      <p:sp>
+        <p:nvSpPr>
+          <p:cNvPr id="16" name="TextBox 15"/>
+          <p:cNvSpPr txBox="1"/>
+          <p:nvPr/>
+        </p:nvSpPr>
+        <p:spPr>
+          <a:xfrm>
+            <a:off x="251999" y="4617720"/>
+            <a:ext cx="2011680" cy="502920"/>
+          </a:xfrm>
+          <a:prstGeom prst="rect">
+            <a:avLst/>
+          </a:prstGeom>
+          <a:noFill/>
+        </p:spPr>
+        <p:txBody>
+          <a:bodyPr wrap="square" lIns="0" rIns="0" tIns="0" bIns="0">
+            <a:spAutoFit/>
+          </a:bodyPr>
+          <a:lstStyle/>
+          <a:p>
+            <a:pPr algn="l"/>
+            <a:r>
+              <a:rPr sz="1800" b="1" i="0">
+                <a:solidFill>
+                  <a:srgbClr val="0B2B4E"/>
+                </a:solidFill>
+                <a:latin typeface="Calibri"/>
+              </a:rPr>
+              <a:t>Combine</a:t>
+            </a:r>
+          </a:p>
+        </p:txBody>
+      </p:sp>
+      <p:sp>
+        <p:nvSpPr>
+          <p:cNvPr id="17" name="TextBox 16"/>
+          <p:cNvSpPr txBox="1"/>
+          <p:nvPr/>
+        </p:nvSpPr>
+        <p:spPr>
+          <a:xfrm>
+            <a:off x="2446559" y="4617720"/>
+            <a:ext cx="9493137" cy="502920"/>
+          </a:xfrm>
+          <a:prstGeom prst="rect">
+            <a:avLst/>
+          </a:prstGeom>
+          <a:noFill/>
+        </p:spPr>
+        <p:txBody>
+          <a:bodyPr wrap="square" lIns="0" rIns="0" tIns="0" bIns="0">
+            <a:spAutoFit/>
+          </a:bodyPr>
+          <a:lstStyle/>
+          <a:p>
+            <a:pPr algn="l"/>
+            <a:r>
+              <a:rPr sz="1800" b="0" i="0">
+                <a:solidFill>
+                  <a:srgbClr val="555B66"/>
+                </a:solidFill>
+                <a:latin typeface="Calibri"/>
+              </a:rPr>
+              <a:t>demand (M2) with cost (M3) to find profit-maximizing price</a:t>
+            </a:r>
+          </a:p>
+        </p:txBody>
+      </p:sp>
+      <p:sp>
+        <p:nvSpPr>
+          <p:cNvPr id="18" name="TextBox 17"/>
+          <p:cNvSpPr txBox="1"/>
+          <p:nvPr/>
+        </p:nvSpPr>
+        <p:spPr>
+          <a:xfrm>
+            <a:off x="251999" y="5120640"/>
+            <a:ext cx="2011680" cy="502920"/>
+          </a:xfrm>
+          <a:prstGeom prst="rect">
+            <a:avLst/>
+          </a:prstGeom>
+          <a:noFill/>
+        </p:spPr>
+        <p:txBody>
+          <a:bodyPr wrap="square" lIns="0" rIns="0" tIns="0" bIns="0">
+            <a:spAutoFit/>
+          </a:bodyPr>
+          <a:lstStyle/>
+          <a:p>
+            <a:pPr algn="l"/>
+            <a:r>
+              <a:rPr sz="1800" b="1" i="0">
+                <a:solidFill>
+                  <a:srgbClr val="0B2B4E"/>
+                </a:solidFill>
+                <a:latin typeface="Calibri"/>
+              </a:rPr>
+              <a:t>Decide</a:t>
+            </a:r>
+          </a:p>
+        </p:txBody>
+      </p:sp>
+      <p:sp>
+        <p:nvSpPr>
+          <p:cNvPr id="19" name="TextBox 18"/>
+          <p:cNvSpPr txBox="1"/>
+          <p:nvPr/>
+        </p:nvSpPr>
+        <p:spPr>
+          <a:xfrm>
+            <a:off x="2446559" y="5120640"/>
+            <a:ext cx="9493137" cy="502920"/>
+          </a:xfrm>
+          <a:prstGeom prst="rect">
+            <a:avLst/>
+          </a:prstGeom>
+          <a:noFill/>
+        </p:spPr>
+        <p:txBody>
+          <a:bodyPr wrap="square" lIns="0" rIns="0" tIns="0" bIns="0">
+            <a:spAutoFit/>
+          </a:bodyPr>
+          <a:lstStyle/>
+          <a:p>
+            <a:pPr algn="l"/>
+            <a:r>
+              <a:rPr sz="1800" b="0" i="0">
+                <a:solidFill>
+                  <a:srgbClr val="555B66"/>
+                </a:solidFill>
+                <a:latin typeface="Calibri"/>
+              </a:rPr>
+              <a:t>how much to produce when each unit costs and earns something different</a:t>
+            </a:r>
+          </a:p>
+        </p:txBody>
+      </p:sp>
+      <p:sp>
+        <p:nvSpPr>
+          <p:cNvPr id="20" name="TextBox 19"/>
+          <p:cNvSpPr txBox="1"/>
+          <p:nvPr/>
+        </p:nvSpPr>
+        <p:spPr>
+          <a:xfrm>
+            <a:off x="251999" y="5623560"/>
+            <a:ext cx="2011680" cy="502920"/>
+          </a:xfrm>
+          <a:prstGeom prst="rect">
+            <a:avLst/>
+          </a:prstGeom>
+          <a:noFill/>
+        </p:spPr>
+        <p:txBody>
+          <a:bodyPr wrap="square" lIns="0" rIns="0" tIns="0" bIns="0">
+            <a:spAutoFit/>
+          </a:bodyPr>
+          <a:lstStyle/>
+          <a:p>
+            <a:pPr algn="l"/>
+            <a:r>
+              <a:rPr sz="1800" b="1" i="0">
+                <a:solidFill>
+                  <a:srgbClr val="0B2B4E"/>
+                </a:solidFill>
+                <a:latin typeface="Calibri"/>
+              </a:rPr>
+              <a:t>Predict</a:t>
+            </a:r>
+          </a:p>
+        </p:txBody>
+      </p:sp>
+      <p:sp>
+        <p:nvSpPr>
+          <p:cNvPr id="21" name="TextBox 20"/>
+          <p:cNvSpPr txBox="1"/>
+          <p:nvPr/>
+        </p:nvSpPr>
+        <p:spPr>
+          <a:xfrm>
+            <a:off x="2446559" y="5623560"/>
+            <a:ext cx="9493137" cy="502920"/>
+          </a:xfrm>
+          <a:prstGeom prst="rect">
+            <a:avLst/>
+          </a:prstGeom>
+          <a:noFill/>
+        </p:spPr>
+        <p:txBody>
+          <a:bodyPr wrap="square" lIns="0" rIns="0" tIns="0" bIns="0">
+            <a:spAutoFit/>
+          </a:bodyPr>
+          <a:lstStyle/>
+          <a:p>
+            <a:pPr algn="l"/>
+            <a:r>
+              <a:rPr sz="1800" b="0" i="0">
+                <a:solidFill>
+                  <a:srgbClr val="555B66"/>
+                </a:solidFill>
+                <a:latin typeface="Calibri"/>
+              </a:rPr>
+              <a:t>how price and quantity respond to cost shocks and demand shifts</a:t>
+            </a:r>
+          </a:p>
+        </p:txBody>
+      </p:sp>
+      <p:sp>
+        <p:nvSpPr>
+          <p:cNvPr id="22" name="Rectangle 21"/>
+          <p:cNvSpPr/>
+          <p:nvPr/>
+        </p:nvSpPr>
+        <p:spPr>
+          <a:xfrm>
+            <a:off x="0" y="6537960"/>
+            <a:ext cx="12191695" cy="18288"/>
+          </a:xfrm>
+          <a:prstGeom prst="rect">
+            <a:avLst/>
+          </a:prstGeom>
+          <a:solidFill>
+            <a:srgbClr val="C8CDD3"/>
+          </a:solidFill>
+          <a:ln>
+            <a:noFill/>
+          </a:ln>
+          <a:effectLst/>
+        </p:spPr>
+        <p:style>
+          <a:lnRef idx="1">
+            <a:schemeClr val="accent1"/>
+          </a:lnRef>
+          <a:fillRef idx="3">
+            <a:schemeClr val="accent1"/>
+          </a:fillRef>
+          <a:effectRef idx="2">
+            <a:schemeClr val="accent1"/>
+          </a:effectRef>
+          <a:fontRef idx="minor">
+            <a:schemeClr val="lt1"/>
+          </a:fontRef>
+        </p:style>
+        <p:txBody>
+          <a:bodyPr rtlCol="0" anchor="ctr"/>
+          <a:lstStyle/>
+          <a:p>
+            <a:pPr algn="ctr"/>
+          </a:p>
+        </p:txBody>
+      </p:sp>
+      <p:sp>
+        <p:nvSpPr>
+          <p:cNvPr id="23" name="Rectangle 22"/>
+          <p:cNvSpPr/>
+          <p:nvPr/>
+        </p:nvSpPr>
+        <p:spPr>
+          <a:xfrm>
+            <a:off x="251999" y="6524244"/>
+            <a:ext cx="2011680" cy="45720"/>
+          </a:xfrm>
+          <a:prstGeom prst="rect">
+            <a:avLst/>
+          </a:prstGeom>
+          <a:solidFill>
+            <a:srgbClr val="E09F3E"/>
+          </a:solidFill>
+          <a:ln>
+            <a:noFill/>
+          </a:ln>
+          <a:effectLst/>
+        </p:spPr>
+        <p:style>
+          <a:lnRef idx="1">
+            <a:schemeClr val="accent1"/>
+          </a:lnRef>
+          <a:fillRef idx="3">
+            <a:schemeClr val="accent1"/>
+          </a:fillRef>
+          <a:effectRef idx="2">
+            <a:schemeClr val="accent1"/>
+          </a:effectRef>
+          <a:fontRef idx="minor">
+            <a:schemeClr val="lt1"/>
+          </a:fontRef>
+        </p:style>
+        <p:txBody>
+          <a:bodyPr rtlCol="0" anchor="ctr"/>
+          <a:lstStyle/>
+          <a:p>
+            <a:pPr algn="ctr"/>
+          </a:p>
+        </p:txBody>
+      </p:sp>
+      <p:sp>
+        <p:nvSpPr>
+          <p:cNvPr id="24" name="TextBox 23"/>
+          <p:cNvSpPr txBox="1"/>
+          <p:nvPr/>
+        </p:nvSpPr>
+        <p:spPr>
+          <a:xfrm>
+            <a:off x="251999" y="6601968"/>
+            <a:ext cx="10058400" cy="274320"/>
+          </a:xfrm>
+          <a:prstGeom prst="rect">
+            <a:avLst/>
+          </a:prstGeom>
+          <a:noFill/>
+        </p:spPr>
+        <p:txBody>
+          <a:bodyPr wrap="square" lIns="0" rIns="0" tIns="0" bIns="0">
+            <a:spAutoFit/>
+          </a:bodyPr>
+          <a:lstStyle/>
+          <a:p>
+            <a:pPr algn="l"/>
+            <a:r>
+              <a:rPr sz="1000" b="0" i="0">
+                <a:solidFill>
+                  <a:srgbClr val="555B66"/>
+                </a:solidFill>
+                <a:latin typeface="Calibri"/>
+              </a:rPr>
+              <a:t>Management 405  ·  Module 3  ·  Production and Costs</a:t>
+            </a:r>
+          </a:p>
+        </p:txBody>
+      </p:sp>
+      <p:sp>
+        <p:nvSpPr>
+          <p:cNvPr id="25" name="TextBox 24"/>
+          <p:cNvSpPr txBox="1"/>
+          <p:nvPr/>
+        </p:nvSpPr>
+        <p:spPr>
+          <a:xfrm>
+            <a:off x="11521440" y="6601968"/>
+            <a:ext cx="457200" cy="274320"/>
+          </a:xfrm>
+          <a:prstGeom prst="rect">
+            <a:avLst/>
+          </a:prstGeom>
+          <a:noFill/>
+        </p:spPr>
+        <p:txBody>
+          <a:bodyPr wrap="square" lIns="0" rIns="0" tIns="0" bIns="0">
+            <a:spAutoFit/>
+          </a:bodyPr>
+          <a:lstStyle/>
+          <a:p>
+            <a:pPr algn="r"/>
+            <a:r>
+              <a:rPr sz="1000" b="0" i="0">
+                <a:solidFill>
+                  <a:srgbClr val="555B66"/>
+                </a:solidFill>
+                <a:latin typeface="Calibri"/>
+              </a:rPr>
+              <a:t>76</a:t>
             </a:r>
           </a:p>
         </p:txBody>

</xml_diff>